<commit_message>
Explain CLEVA evaluation naturally and remove production-level details
</commit_message>
<xml_diff>
--- a/slides/datasets-in-10-minutes-cleva.pptx
+++ b/slides/datasets-in-10-minutes-cleva.pptx
@@ -10,7 +10,6 @@
     <p:sldId id="258" r:id="rId8"/>
     <p:sldId id="259" r:id="rId9"/>
     <p:sldId id="260" r:id="rId10"/>
-    <p:sldId id="261" r:id="rId5"/>
     <p:sldId id="262" r:id="rId4"/>
     <p:sldId id="263" r:id="rId3"/>
     <p:sldId id="264" r:id="rId2"/>
@@ -34,10 +33,8 @@
     <p:sldId id="282" r:id="rId32"/>
     <p:sldId id="283" r:id="rId33"/>
     <p:sldId id="284" r:id="rId34"/>
-    <p:sldId id="285" r:id="rId35"/>
     <p:sldId id="286" r:id="rId36"/>
     <p:sldId id="287" r:id="rId37"/>
-    <p:sldId id="288" r:id="rId38"/>
     <p:sldId id="289" r:id="rId39"/>
     <p:sldId id="290" r:id="rId40"/>
     <p:sldId id="291" r:id="rId41"/>
@@ -61,7 +58,6 @@
     <p:sldId id="309" r:id="rId59"/>
     <p:sldId id="310" r:id="rId60"/>
     <p:sldId id="311" r:id="rId61"/>
-    <p:sldId id="312" r:id="rId62"/>
     <p:sldId id="313" r:id="rId63"/>
     <p:sldId id="314" r:id="rId64"/>
     <p:sldId id="315" r:id="rId65"/>
@@ -342,7 +338,7 @@
               <c:strCache>
                 <c:ptCount val="1"/>
                 <c:pt idx="0">
-                  <c:v>文書数</c:v>
+                  <c:v>課題数</c:v>
                 </c:pt>
               </c:strCache>
             </c:strRef>
@@ -376,10 +372,10 @@
                 <c:formatCode>General</c:formatCode>
                 <c:ptCount val="2"/>
                 <c:pt idx="0">
-                  <c:v>20</c:v>
+                  <c:v>20.0</c:v>
                 </c:pt>
                 <c:pt idx="1">
-                  <c:v>11</c:v>
+                  <c:v>11.0</c:v>
                 </c:pt>
               </c:numCache>
             </c:numRef>
@@ -7393,11 +7389,11 @@
         <p:spPr>
           <a:xfrm>
             <a:off x="548640" y="2647277"/>
-            <a:ext cx="8046720" cy="989965"/>
+            <a:ext cx="8046720" cy="1091565"/>
           </a:xfrm>
         </p:spPr>
         <p:txBody>
-          <a:bodyPr lIns="0" rIns="0" tIns="0" bIns="0">
+          <a:bodyPr lIns="0" rIns="0" tIns="0" bIns="101600">
             <a:noAutofit/>
           </a:bodyPr>
           <a:lstStyle/>
@@ -8044,7 +8040,7 @@
                 <a:ea typeface="Noto Sans CJK JP"/>
                 <a:cs typeface="Noto Sans"/>
               </a:rPr>
-              <a:t>D. 父親が大きな重圧を感じている</a:t>
+              <a:t>D. 父親にかかる重圧が大きすぎる</a:t>
             </a:r>
           </a:p>
         </p:txBody>
@@ -8152,7 +8148,7 @@
                 <a:ea typeface="Noto Sans CJK JP"/>
                 <a:cs typeface="Noto Sans"/>
               </a:rPr>
-              <a:t>[1] Li, Zhao et al. (2023), CLEVA. 公開説明例。 公開例 A2.SS2.SSS0.Px1 ／ C3。</a:t>
+              <a:t>[1] Li et al. (2023). CLEVA. 公開説明例。</a:t>
             </a:r>
             <a:r>
               <a:rPr sz="810" b="0" lang="ja-JP" altLang="en-US">
@@ -8324,7 +8320,7 @@
                 <a:ea typeface="Noto Sans CJK JP"/>
                 <a:cs typeface="Noto Sans"/>
               </a:rPr>
-              <a:t>忙しいのは父親であり、選択肢Cの「息子が忙しい」とは異なる。原文、質問、全選択肢の対応を保つことが、評価の前提になる。</a:t>
+              <a:t>忙しいのは父親であり、選択肢Cの「息子が忙しい」とは異なる。文中の人物と理由を結び付け、最も合う選択肢を選ぶ。</a:t>
             </a:r>
           </a:p>
         </p:txBody>
@@ -8426,7 +8422,7 @@
                 <a:ea typeface="Noto Sans CJK JP"/>
                 <a:cs typeface="Noto Sans"/>
               </a:rPr>
-              <a:t>[1] Li, Zhao et al. (2023), CLEVA: Chinese Language Models EVAluation Platform. EMNLP System Demonstrations.</a:t>
+              <a:t>[1] Li et al. (2023). CLEVA. EMNLP System Demonstrations.</a:t>
             </a:r>
             <a:r>
               <a:rPr sz="810" b="0" lang="ja-JP" altLang="en-US">
@@ -9012,7 +9008,7 @@
                 <a:ea typeface="Noto Sans CJK JP"/>
                 <a:cs typeface="Noto Sans"/>
               </a:rPr>
-              <a:t>[1] Li, Zhao et al. (2023), CLEVA. 公開説明例。 公開例 A2.SS1.SSS3.Px2 ／ 数学的推論。</a:t>
+              <a:t>[1] Li et al. (2023). CLEVA. 公開説明例。</a:t>
             </a:r>
             <a:r>
               <a:rPr sz="810" b="0" lang="ja-JP" altLang="en-US">
@@ -9316,7 +9312,7 @@
                 <a:ea typeface="Noto Sans CJK JP"/>
                 <a:cs typeface="Noto Sans"/>
               </a:rPr>
-              <a:t>[1] Li, Zhao et al. (2023), CLEVA: Chinese Language Models EVAluation Platform. EMNLP System Demonstrations.</a:t>
+              <a:t>[1] Li et al. (2023). CLEVA. EMNLP System Demonstrations.</a:t>
             </a:r>
             <a:r>
               <a:rPr sz="810" b="0" lang="ja-JP" altLang="en-US">
@@ -9734,7 +9730,7 @@
                 <a:ea typeface="Noto Sans CJK JP"/>
                 <a:cs typeface="Noto Sans"/>
               </a:rPr>
-              <a:t>[1] Li, Zhao et al. (2023), CLEVA: Chinese Language Models EVAluation Platform. EMNLP System Demonstrations.</a:t>
+              <a:t>[1] Li et al. (2023). CLEVA. EMNLP System Demonstrations.</a:t>
             </a:r>
             <a:r>
               <a:rPr sz="810" b="0" lang="ja-JP" altLang="en-US">
@@ -9896,61 +9892,7 @@
       </p:graphicFrame>
       <p:sp>
         <p:nvSpPr>
-          <p:cNvPr id="5" name="TextBox 4"/>
-          <p:cNvSpPr txBox="1"/>
-          <p:nvPr/>
-        </p:nvSpPr>
-        <p:spPr>
-          <a:xfrm>
-            <a:off x="594360" y="3968496"/>
-            <a:ext cx="7955279" cy="566928"/>
-          </a:xfrm>
-          <a:prstGeom prst="rect">
-            <a:avLst/>
-          </a:prstGeom>
-          <a:noFill/>
-        </p:spPr>
-        <p:txBody>
-          <a:bodyPr wrap="square" lIns="0" rIns="0" tIns="0" bIns="0">
-            <a:noAutofit/>
-          </a:bodyPr>
-          <a:lstStyle/>
-          <a:p>
-            <a:pPr algn="l">
-              <a:lnSpc>
-                <a:spcPts val="2160"/>
-              </a:lnSpc>
-              <a:spcBef>
-                <a:spcPts val="0"/>
-              </a:spcBef>
-              <a:spcAft>
-                <a:spcPts val="0"/>
-              </a:spcAft>
-              <a:buNone/>
-              <a:defRPr sz="1750" b="0">
-                <a:solidFill>
-                  <a:srgbClr val="303437"/>
-                </a:solidFill>
-                <a:latin typeface="Noto Sans"/>
-              </a:defRPr>
-            </a:pPr>
-            <a:r>
-              <a:rPr sz="1750" b="0" lang="ja-JP" altLang="en-US">
-                <a:solidFill>
-                  <a:srgbClr val="303437"/>
-                </a:solidFill>
-                <a:latin typeface="Noto Sans"/>
-                <a:ea typeface="Noto Sans CJK JP"/>
-                <a:cs typeface="Noto Sans"/>
-              </a:rPr>
-              <a:t>31は課題の種類。収録データセット数や、実際にモデルへ送る問い合わせ数とは異なる。</a:t>
-            </a:r>
-          </a:p>
-        </p:txBody>
-      </p:sp>
-      <p:sp>
-        <p:nvSpPr>
-          <p:cNvPr id="6" name="sources"/>
+          <p:cNvPr id="5" name="sources"/>
           <p:cNvSpPr txBox="1"/>
           <p:nvPr/>
         </p:nvSpPr>
@@ -9997,7 +9939,7 @@
                 <a:ea typeface="Noto Sans CJK JP"/>
                 <a:cs typeface="Noto Sans"/>
               </a:rPr>
-              <a:t>[1] Li, Zhao et al. (2023), CLEVA: Chinese Language Models EVAluation Platform. EMNLP System Demonstrations.</a:t>
+              <a:t>[1] Li et al. (2023). CLEVA. EMNLP System Demonstrations.</a:t>
             </a:r>
             <a:r>
               <a:rPr sz="810" b="0" lang="ja-JP" altLang="en-US">
@@ -10746,7 +10688,7 @@
                 <a:ea typeface="Noto Sans CJK JP"/>
                 <a:cs typeface="Noto Sans"/>
               </a:rPr>
-              <a:t>[1] Li, Zhao et al. (2023), CLEVA: Chinese Language Models EVAluation Platform. EMNLP System Demonstrations.</a:t>
+              <a:t>[1] Li et al. (2023). CLEVA. EMNLP System Demonstrations.</a:t>
             </a:r>
             <a:r>
               <a:rPr sz="810" b="0" lang="ja-JP" altLang="en-US">
@@ -11094,7 +11036,7 @@
                 <a:ea typeface="Noto Sans CJK JP"/>
                 <a:cs typeface="Noto Sans"/>
               </a:rPr>
-              <a:t>[1] Li, Zhao et al. (2023), CLEVA: Chinese Language Models EVAluation Platform. EMNLP System Demonstrations.</a:t>
+              <a:t>[1] Li et al. (2023). CLEVA. EMNLP System Demonstrations.</a:t>
             </a:r>
             <a:r>
               <a:rPr sz="810" b="0" lang="ja-JP" altLang="en-US">
@@ -11398,7 +11340,7 @@
                 <a:ea typeface="Noto Sans CJK JP"/>
                 <a:cs typeface="Noto Sans"/>
               </a:rPr>
-              <a:t>[1] Li, Zhao et al. (2023), CLEVA: Chinese Language Models EVAluation Platform. EMNLP System Demonstrations.</a:t>
+              <a:t>[1] Li et al. (2023). CLEVA. EMNLP System Demonstrations.</a:t>
             </a:r>
             <a:r>
               <a:rPr sz="810" b="0" lang="ja-JP" altLang="en-US">
@@ -11613,7 +11555,7 @@
                 <a:ea typeface="Noto Sans CJK JP"/>
                 <a:cs typeface="Noto Sans"/>
               </a:rPr>
-              <a:t>[1] LaVi Lab, CLEVA. 公式README・ローカル評価・参照結果・利用条件。 README冒頭のブラウザ画面。</a:t>
+              <a:t>[1] LaVi Lab. CLEVA公式リポジトリ。</a:t>
             </a:r>
             <a:r>
               <a:rPr sz="810" b="0" lang="ja-JP" altLang="en-US">
@@ -12464,7 +12406,7 @@
                 <a:ea typeface="Noto Sans CJK JP"/>
                 <a:cs typeface="Noto Sans"/>
               </a:rPr>
-              <a:t>[1] Li, Zhao et al. (2023), CLEVA: Chinese Language Models EVAluation Platform. EMNLP System Demonstrations.</a:t>
+              <a:t>[1] Li et al. (2023). CLEVA. EMNLP System Demonstrations.</a:t>
             </a:r>
             <a:r>
               <a:rPr sz="810" b="0" lang="ja-JP" altLang="en-US">
@@ -13267,7 +13209,7 @@
                 <a:ea typeface="Noto Sans CJK JP"/>
                 <a:cs typeface="Noto Sans"/>
               </a:rPr>
-              <a:t>[1] Li, Zhao et al. (2023), CLEVA: Chinese Language Models EVAluation Platform. EMNLP System Demonstrations.</a:t>
+              <a:t>[1] Li et al. (2023). CLEVA. EMNLP System Demonstrations.</a:t>
             </a:r>
             <a:r>
               <a:rPr sz="810" b="0" lang="ja-JP" altLang="en-US">
@@ -13356,7 +13298,7 @@
                 <a:ea typeface="Noto Sans CJK JP"/>
                 <a:cs typeface="Noto Sans"/>
               </a:rPr>
-              <a:t>分類課題と、生成文の測定を分ける</a:t>
+              <a:t>与えられた文の分類と、生成文の測定</a:t>
             </a:r>
           </a:p>
         </p:txBody>
@@ -13409,7 +13351,7 @@
                 <a:ea typeface="Noto Sans CJK JP"/>
                 <a:cs typeface="Noto Sans"/>
               </a:rPr>
-              <a:t>COLDによる有害表現の検出や、CDial-Biasによる偏りの判定は、与えられた文を分類する課題。</a:t>
+              <a:t>COLDによる有害表現の検出や、CDial-Biasによる偏見の判定では、与えられた文に分類ラベルを付ける。</a:t>
             </a:r>
           </a:p>
           <a:p>
@@ -13439,37 +13381,7 @@
                 <a:ea typeface="Noto Sans CJK JP"/>
                 <a:cs typeface="Noto Sans"/>
               </a:rPr>
-              <a:t>一方、有害性や偏りを生成文から測る指標は、モデルが書いた内容を調べる。分類の正答率が高いことだけでは、生成文の性質までは分からない。</a:t>
-            </a:r>
-          </a:p>
-          <a:p>
-            <a:pPr marL="457200" indent="-355600">
-              <a:lnSpc>
-                <a:spcPts val="2618"/>
-              </a:lnSpc>
-              <a:spcAft>
-                <a:spcPts val="0"/>
-              </a:spcAft>
-              <a:buSzPct val="60455"/>
-              <a:buFont typeface="Noto Sans CJK JP"/>
-              <a:buChar char="●"/>
-              <a:defRPr sz="2200" b="0">
-                <a:solidFill>
-                  <a:srgbClr val="303437"/>
-                </a:solidFill>
-                <a:latin typeface="Noto Sans"/>
-              </a:defRPr>
-            </a:pPr>
-            <a:r>
-              <a:rPr sz="2200" b="0" lang="ja-JP" altLang="en-US">
-                <a:solidFill>
-                  <a:srgbClr val="303437"/>
-                </a:solidFill>
-                <a:latin typeface="Noto Sans"/>
-                <a:ea typeface="Noto Sans CJK JP"/>
-                <a:cs typeface="Noto Sans"/>
-              </a:rPr>
-              <a:t>課題名が似ていても、入力・出力・測る対象を対応させて結果を読む。</a:t>
+              <a:t>有害性や偏りを生成文から測る指標では、モデルが書いた応答を調べる。同じモデルについて、入力文を判定する能力と、自身の応答に現れる性質の両面を評価する。</a:t>
             </a:r>
           </a:p>
         </p:txBody>
@@ -13571,7 +13483,7 @@
                 <a:ea typeface="Noto Sans CJK JP"/>
                 <a:cs typeface="Noto Sans"/>
               </a:rPr>
-              <a:t>[1] Li, Zhao et al. (2023), CLEVA: Chinese Language Models EVAluation Platform. EMNLP System Demonstrations.</a:t>
+              <a:t>[1] Li et al. (2023). CLEVA. EMNLP System Demonstrations.</a:t>
             </a:r>
             <a:r>
               <a:rPr sz="810" b="0" lang="ja-JP" altLang="en-US">
@@ -13774,7 +13686,7 @@
                 <a:ea typeface="Noto Sans CJK JP"/>
                 <a:cs typeface="Noto Sans"/>
               </a:rPr>
-              <a:t>件数の単位を区別する</a:t>
+              <a:t>31課題・84データセットから、約37万事例</a:t>
             </a:r>
           </a:p>
         </p:txBody>
@@ -13876,7 +13788,7 @@
                           <a:ea typeface="Noto Sans CJK JP"/>
                           <a:cs typeface="Noto Sans"/>
                         </a:rPr>
-                        <a:t>単位</a:t>
+                        <a:t>規模の項目</a:t>
                       </a:r>
                     </a:p>
                   </a:txBody>
@@ -14536,7 +14448,7 @@
                 <a:ea typeface="Noto Sans CJK JP"/>
                 <a:cs typeface="Noto Sans"/>
               </a:rPr>
-              <a:t>[1] Li, Zhao et al. (2023), CLEVA: Chinese Language Models EVAluation Platform. EMNLP System Demonstrations.</a:t>
+              <a:t>[1] Li et al. (2023). CLEVA. EMNLP System Demonstrations.</a:t>
             </a:r>
             <a:r>
               <a:rPr sz="810" b="0" lang="ja-JP" altLang="en-US">
@@ -14840,7 +14752,7 @@
                 <a:ea typeface="Noto Sans CJK JP"/>
                 <a:cs typeface="Noto Sans"/>
               </a:rPr>
-              <a:t>[1] Li, Zhao et al. (2023), CLEVA: Chinese Language Models EVAluation Platform. EMNLP System Demonstrations.</a:t>
+              <a:t>[1] Li et al. (2023). CLEVA. EMNLP System Demonstrations.</a:t>
             </a:r>
             <a:r>
               <a:rPr sz="810" b="0" lang="ja-JP" altLang="en-US">
@@ -14982,7 +14894,7 @@
                 <a:ea typeface="Noto Sans CJK JP"/>
                 <a:cs typeface="Noto Sans"/>
               </a:rPr>
-              <a:t>すべての課題から同じ割合を抜くのではなく、モデル間の順位を区別できるかという基準に応じて、課題ごとの抽出量を調整する。</a:t>
+              <a:t>課題ごとの抽出量は、モデル間の順位を判別できるかという基準で調整する。</a:t>
             </a:r>
           </a:p>
           <a:p>
@@ -15012,37 +14924,7 @@
                 <a:ea typeface="Noto Sans CJK JP"/>
                 <a:cs typeface="Noto Sans"/>
               </a:rPr>
-              <a:t>報告する基準は、許容する近似誤差の範囲で、任意のモデル対を正しく順位付けする確率が少なくとも70%となること。</a:t>
-            </a:r>
-          </a:p>
-          <a:p>
-            <a:pPr marL="457200" indent="-355600">
-              <a:lnSpc>
-                <a:spcPts val="2558"/>
-              </a:lnSpc>
-              <a:spcAft>
-                <a:spcPts val="0"/>
-              </a:spcAft>
-              <a:buSzPct val="61860"/>
-              <a:buFont typeface="Noto Sans CJK JP"/>
-              <a:buChar char="●"/>
-              <a:defRPr sz="2150" b="0">
-                <a:solidFill>
-                  <a:srgbClr val="303437"/>
-                </a:solidFill>
-                <a:latin typeface="Noto Sans"/>
-              </a:defRPr>
-            </a:pPr>
-            <a:r>
-              <a:rPr sz="2150" b="0" lang="ja-JP" altLang="en-US">
-                <a:solidFill>
-                  <a:srgbClr val="303437"/>
-                </a:solidFill>
-                <a:latin typeface="Noto Sans"/>
-                <a:ea typeface="Noto Sans CJK JP"/>
-                <a:cs typeface="Noto Sans"/>
-              </a:rPr>
-              <a:t>この70%は、モデルの問題正答率でも、全モデルを完全に並べ替えられる確率でもない。</a:t>
+              <a:t>許容する近似誤差の範囲で、任意のモデル対を正しく順位付けする確率が少なくとも70％となるよう、評価に使う件数を決める。</a:t>
             </a:r>
           </a:p>
         </p:txBody>
@@ -15144,7 +15026,7 @@
                 <a:ea typeface="Noto Sans CJK JP"/>
                 <a:cs typeface="Noto Sans"/>
               </a:rPr>
-              <a:t>[1] Li, Zhao et al. (2023), CLEVA: Chinese Language Models EVAluation Platform. EMNLP System Demonstrations.</a:t>
+              <a:t>[1] Li et al. (2023). CLEVA. EMNLP System Demonstrations.</a:t>
             </a:r>
             <a:r>
               <a:rPr sz="810" b="0" lang="ja-JP" altLang="en-US">
@@ -15286,7 +15168,7 @@
                 <a:ea typeface="Noto Sans CJK JP"/>
                 <a:cs typeface="Noto Sans"/>
               </a:rPr>
-              <a:t>公開時の実験では、APIで利用するモデルと、重みが公開されたモデルの計23種を、中国語の課題で比較した。モデル一覧と、利用時点が分かるAPI版を記載している。</a:t>
+              <a:t>公開時の実験では、APIで利用するモデルと、重みが公開されたモデルの計23種を、中国語の課題で比較した。</a:t>
             </a:r>
           </a:p>
           <a:p>
@@ -15316,37 +15198,7 @@
                 <a:ea typeface="Noto Sans CJK JP"/>
                 <a:cs typeface="Noto Sans"/>
               </a:rPr>
-              <a:t>同じモデルでも、課題や評価軸によって結果が異なる。課題別の性能と、複数プロンプトでの変動を合わせて見る構成である。</a:t>
-            </a:r>
-          </a:p>
-          <a:p>
-            <a:pPr marL="457200" indent="-355600">
-              <a:lnSpc>
-                <a:spcPts val="2439"/>
-              </a:lnSpc>
-              <a:spcAft>
-                <a:spcPts val="0"/>
-              </a:spcAft>
-              <a:buSzPct val="64878"/>
-              <a:buFont typeface="Noto Sans CJK JP"/>
-              <a:buChar char="●"/>
-              <a:defRPr sz="2050" b="0">
-                <a:solidFill>
-                  <a:srgbClr val="303437"/>
-                </a:solidFill>
-                <a:latin typeface="Noto Sans"/>
-              </a:defRPr>
-            </a:pPr>
-            <a:r>
-              <a:rPr sz="2050" b="0" lang="ja-JP" altLang="en-US">
-                <a:solidFill>
-                  <a:srgbClr val="303437"/>
-                </a:solidFill>
-                <a:latin typeface="Noto Sans"/>
-                <a:ea typeface="Noto Sans CJK JP"/>
-                <a:cs typeface="Noto Sans"/>
-              </a:rPr>
-              <a:t>これは2023年の結果であり、その後のモデルの順位を示すものではない。次に、公式READMEが示すHELMでの参照結果を見る。</a:t>
+              <a:t>同じモデルでも、課題や評価軸によって結果が異なる。課題別の性能と、複数プロンプトでの変動を合わせて示している。</a:t>
             </a:r>
           </a:p>
         </p:txBody>
@@ -15448,7 +15300,7 @@
                 <a:ea typeface="Noto Sans CJK JP"/>
                 <a:cs typeface="Noto Sans"/>
               </a:rPr>
-              <a:t>[1] Li, Zhao et al. (2023), CLEVA: Chinese Language Models EVAluation Platform. EMNLP System Demonstrations.</a:t>
+              <a:t>[1] Li et al. (2023). CLEVA. EMNLP System Demonstrations.</a:t>
             </a:r>
             <a:r>
               <a:rPr sz="810" b="0" lang="ja-JP" altLang="en-US">
@@ -15537,7 +15389,7 @@
                 <a:ea typeface="Noto Sans CJK JP"/>
                 <a:cs typeface="Noto Sans"/>
               </a:rPr>
-              <a:t>提示例は、多ければよいとは限らない</a:t>
+              <a:t>例示を増やす効果は、課題によって異なる</a:t>
             </a:r>
           </a:p>
         </p:txBody>
@@ -15623,36 +15475,6 @@
               <a:t>一方、文章分類では、提示例を増やすと性能が下がるモデルも見られた。著者は、ラベルの種類が多く、例の追加が判断を妨げた可能性を挙げている。</a:t>
             </a:r>
           </a:p>
-          <a:p>
-            <a:pPr marL="457200" indent="-355600">
-              <a:lnSpc>
-                <a:spcPts val="2499"/>
-              </a:lnSpc>
-              <a:spcAft>
-                <a:spcPts val="0"/>
-              </a:spcAft>
-              <a:buSzPct val="63333"/>
-              <a:buFont typeface="Noto Sans CJK JP"/>
-              <a:buChar char="●"/>
-              <a:defRPr sz="2100" b="0">
-                <a:solidFill>
-                  <a:srgbClr val="303437"/>
-                </a:solidFill>
-                <a:latin typeface="Noto Sans"/>
-              </a:defRPr>
-            </a:pPr>
-            <a:r>
-              <a:rPr sz="2100" b="0" lang="ja-JP" altLang="en-US">
-                <a:solidFill>
-                  <a:srgbClr val="303437"/>
-                </a:solidFill>
-                <a:latin typeface="Noto Sans"/>
-                <a:ea typeface="Noto Sans CJK JP"/>
-                <a:cs typeface="Noto Sans"/>
-              </a:rPr>
-              <a:t>これは31課題すべてに共通する最適例数の報告ではない。モデル、課題、入力形式を固定した比較として読む。</a:t>
-            </a:r>
-          </a:p>
         </p:txBody>
       </p:sp>
       <p:sp>
@@ -15752,7 +15574,7 @@
                 <a:ea typeface="Noto Sans CJK JP"/>
                 <a:cs typeface="Noto Sans"/>
               </a:rPr>
-              <a:t>[1] Li, Zhao et al. (2023), CLEVA: Chinese Language Models EVAluation Platform. EMNLP System Demonstrations.</a:t>
+              <a:t>[1] Li et al. (2023). CLEVA. EMNLP System Demonstrations.</a:t>
             </a:r>
             <a:r>
               <a:rPr sz="810" b="0" lang="ja-JP" altLang="en-US">
@@ -16724,7 +16546,7 @@
         <p:spPr>
           <a:xfrm>
             <a:off x="594360" y="3813048"/>
-            <a:ext cx="7955279" cy="658368"/>
+            <a:ext cx="7955279" cy="667512"/>
           </a:xfrm>
           <a:prstGeom prst="rect">
             <a:avLst/>
@@ -16764,7 +16586,7 @@
                 <a:ea typeface="Noto Sans CJK JP"/>
                 <a:cs typeface="Noto Sans"/>
               </a:rPr>
-              <a:t>gpt-3.5-turbo-0613を用いた公式READMEの比較。指標と尺度が異なるため、行をまたぐ平均は取らない。</a:t>
+              <a:t>公式READMEのgpt-3.5-turbo-0613による比較。提示例の抽出とChatGPTの版の違いが、差の主な理由として挙げられる。</a:t>
             </a:r>
           </a:p>
         </p:txBody>
@@ -16818,7 +16640,7 @@
                 <a:ea typeface="Noto Sans CJK JP"/>
                 <a:cs typeface="Noto Sans"/>
               </a:rPr>
-              <a:t>[1] LaVi Lab, CLEVA. 公式README・ローカル評価・参照結果・利用条件。</a:t>
+              <a:t>[1] LaVi Lab. CLEVA公式リポジトリ。</a:t>
             </a:r>
             <a:r>
               <a:rPr sz="810" b="0" lang="ja-JP" altLang="en-US">
@@ -17050,7 +16872,7 @@
                 <a:ea typeface="Noto Sans CJK JP"/>
                 <a:cs typeface="Noto Sans"/>
               </a:rPr>
-              <a:t>HELMでの利用と公開範囲</a:t>
+              <a:t>HELMを使った評価とデータの入手</a:t>
             </a:r>
           </a:p>
         </p:txBody>
@@ -17099,280 +16921,6 @@
                 <a:cs typeface="Noto Sans"/>
               </a:rPr>
               <a:t>目次</a:t>
-            </a:r>
-          </a:p>
-        </p:txBody>
-      </p:sp>
-    </p:spTree>
-  </p:cSld>
-  <p:clrMapOvr>
-    <a:masterClrMapping/>
-  </p:clrMapOvr>
-</p:sld>
-</file>
-
-<file path=ppt/slides/slide30.xml><?xml version="1.0" encoding="utf-8"?>
-<p:sld xmlns:a="http://schemas.openxmlformats.org/drawingml/2006/main" xmlns:p="http://schemas.openxmlformats.org/presentationml/2006/main" xmlns:r="http://schemas.openxmlformats.org/officeDocument/2006/relationships">
-  <p:cSld>
-    <p:spTree>
-      <p:nvGrpSpPr>
-        <p:cNvPr id="1" name=""/>
-        <p:cNvGrpSpPr/>
-        <p:nvPr/>
-      </p:nvGrpSpPr>
-      <p:grpSpPr/>
-      <p:sp>
-        <p:nvSpPr>
-          <p:cNvPr id="2" name="Title 1"/>
-          <p:cNvSpPr>
-            <a:spLocks noGrp="1"/>
-          </p:cNvSpPr>
-          <p:nvPr>
-            <p:ph type="title"/>
-          </p:nvPr>
-        </p:nvSpPr>
-        <p:spPr>
-          <a:xfrm>
-            <a:off x="468172" y="650138"/>
-            <a:ext cx="8206740" cy="616305"/>
-          </a:xfrm>
-        </p:spPr>
-        <p:txBody>
-          <a:bodyPr wrap="square" lIns="0" rIns="0" tIns="0" bIns="0">
-            <a:noAutofit/>
-          </a:bodyPr>
-          <a:lstStyle/>
-          <a:p>
-            <a:pPr algn="l">
-              <a:lnSpc>
-                <a:spcPct val="110000"/>
-              </a:lnSpc>
-              <a:buNone/>
-              <a:defRPr sz="2800" b="0">
-                <a:solidFill>
-                  <a:srgbClr val="303437"/>
-                </a:solidFill>
-                <a:latin typeface="Noto Sans"/>
-              </a:defRPr>
-            </a:pPr>
-            <a:r>
-              <a:rPr sz="2800" b="1" lang="ja-JP" altLang="en-US">
-                <a:solidFill>
-                  <a:srgbClr val="303437"/>
-                </a:solidFill>
-                <a:latin typeface="Noto Sans"/>
-                <a:ea typeface="Noto Sans CJK JP"/>
-                <a:cs typeface="Noto Sans"/>
-              </a:rPr>
-              <a:t>小さな差も、条件の違いとともに読む</a:t>
-            </a:r>
-          </a:p>
-        </p:txBody>
-      </p:sp>
-      <p:sp>
-        <p:nvSpPr>
-          <p:cNvPr id="3" name="Text Placeholder 2"/>
-          <p:cNvSpPr>
-            <a:spLocks noGrp="1"/>
-          </p:cNvSpPr>
-          <p:nvPr>
-            <p:ph type="body" idx="1"/>
-          </p:nvPr>
-        </p:nvSpPr>
-        <p:spPr>
-          <a:xfrm>
-            <a:off x="594360" y="1463040"/>
-            <a:ext cx="7955279" cy="3044952"/>
-          </a:xfrm>
-        </p:spPr>
-        <p:txBody>
-          <a:bodyPr wrap="square" tIns="91440" bIns="91440">
-            <a:noAutofit/>
-          </a:bodyPr>
-          <a:lstStyle/>
-          <a:p>
-            <a:pPr marL="457200" indent="-355600">
-              <a:lnSpc>
-                <a:spcPts val="2736"/>
-              </a:lnSpc>
-              <a:spcAft>
-                <a:spcPts val="700"/>
-              </a:spcAft>
-              <a:buSzPct val="57826"/>
-              <a:buFont typeface="Noto Sans CJK JP"/>
-              <a:buChar char="●"/>
-              <a:defRPr sz="2300" b="0">
-                <a:solidFill>
-                  <a:srgbClr val="303437"/>
-                </a:solidFill>
-                <a:latin typeface="Noto Sans"/>
-              </a:defRPr>
-            </a:pPr>
-            <a:r>
-              <a:rPr sz="2300" b="0" lang="ja-JP" altLang="en-US">
-                <a:solidFill>
-                  <a:srgbClr val="303437"/>
-                </a:solidFill>
-                <a:latin typeface="Noto Sans"/>
-                <a:ea typeface="Noto Sans CJK JP"/>
-                <a:cs typeface="Noto Sans"/>
-              </a:rPr>
-              <a:t>公式READMEは、乱数の違いで文脈内の提示例が変わることと、CLEVAとHELMで使ったChatGPTの版が完全には一致しないことを、得点差の主な理由としている。</a:t>
-            </a:r>
-          </a:p>
-          <a:p>
-            <a:pPr marL="457200" indent="-355600">
-              <a:lnSpc>
-                <a:spcPts val="2736"/>
-              </a:lnSpc>
-              <a:spcAft>
-                <a:spcPts val="0"/>
-              </a:spcAft>
-              <a:buSzPct val="57826"/>
-              <a:buFont typeface="Noto Sans CJK JP"/>
-              <a:buChar char="●"/>
-              <a:defRPr sz="2300" b="0">
-                <a:solidFill>
-                  <a:srgbClr val="303437"/>
-                </a:solidFill>
-                <a:latin typeface="Noto Sans"/>
-              </a:defRPr>
-            </a:pPr>
-            <a:r>
-              <a:rPr sz="2300" b="0" lang="ja-JP" altLang="en-US">
-                <a:solidFill>
-                  <a:srgbClr val="303437"/>
-                </a:solidFill>
-                <a:latin typeface="Noto Sans"/>
-                <a:ea typeface="Noto Sans CJK JP"/>
-                <a:cs typeface="Noto Sans"/>
-              </a:rPr>
-              <a:t>前ページの値は、同じ条件の二重測定による誤差だけを示すものではない。プロンプト、提示例、モデル版をそろえてから比較する。</a:t>
-            </a:r>
-          </a:p>
-        </p:txBody>
-      </p:sp>
-      <p:sp>
-        <p:nvSpPr>
-          <p:cNvPr id="4" name="Title 3"/>
-          <p:cNvSpPr>
-            <a:spLocks noGrp="1"/>
-          </p:cNvSpPr>
-          <p:nvPr>
-            <p:ph type="title" idx="2"/>
-          </p:nvPr>
-        </p:nvSpPr>
-        <p:spPr>
-          <a:xfrm>
-            <a:off x="75895" y="0"/>
-            <a:ext cx="8115300" cy="480060"/>
-          </a:xfrm>
-        </p:spPr>
-        <p:txBody>
-          <a:bodyPr wrap="square" lIns="0" rIns="0" tIns="0" bIns="0" anchor="ctr">
-            <a:noAutofit/>
-          </a:bodyPr>
-          <a:lstStyle/>
-          <a:p>
-            <a:pPr algn="l">
-              <a:lnSpc>
-                <a:spcPct val="110000"/>
-              </a:lnSpc>
-              <a:buNone/>
-              <a:defRPr sz="1400" b="0">
-                <a:solidFill>
-                  <a:srgbClr val="303437"/>
-                </a:solidFill>
-                <a:latin typeface="Noto Sans"/>
-              </a:defRPr>
-            </a:pPr>
-            <a:r>
-              <a:rPr sz="1400" b="1" lang="ja-JP" altLang="en-US">
-                <a:solidFill>
-                  <a:srgbClr val="FFFEF8"/>
-                </a:solidFill>
-                <a:latin typeface="Noto Sans"/>
-                <a:ea typeface="Noto Sans CJK JP"/>
-                <a:cs typeface="Noto Sans"/>
-              </a:rPr>
-              <a:t>3. 新しい評価集合と比較の条件</a:t>
-            </a:r>
-          </a:p>
-        </p:txBody>
-      </p:sp>
-      <p:sp>
-        <p:nvSpPr>
-          <p:cNvPr id="5" name="sources"/>
-          <p:cNvSpPr txBox="1"/>
-          <p:nvPr/>
-        </p:nvSpPr>
-        <p:spPr>
-          <a:xfrm>
-            <a:off x="502920" y="4700016"/>
-            <a:ext cx="8183879" cy="530352"/>
-          </a:xfrm>
-          <a:prstGeom prst="rect">
-            <a:avLst/>
-          </a:prstGeom>
-          <a:noFill/>
-        </p:spPr>
-        <p:txBody>
-          <a:bodyPr wrap="square" lIns="0" rIns="0" tIns="0" bIns="0">
-            <a:noAutofit/>
-          </a:bodyPr>
-          <a:lstStyle/>
-          <a:p>
-            <a:pPr algn="l">
-              <a:lnSpc>
-                <a:spcPts val="940"/>
-              </a:lnSpc>
-              <a:spcBef>
-                <a:spcPts val="0"/>
-              </a:spcBef>
-              <a:spcAft>
-                <a:spcPts val="140"/>
-              </a:spcAft>
-              <a:buNone/>
-              <a:defRPr sz="810" b="0">
-                <a:solidFill>
-                  <a:srgbClr val="303437"/>
-                </a:solidFill>
-                <a:latin typeface="Noto Sans"/>
-              </a:defRPr>
-            </a:pPr>
-            <a:r>
-              <a:rPr sz="810" b="0" lang="ja-JP" altLang="en-US">
-                <a:solidFill>
-                  <a:srgbClr val="626669"/>
-                </a:solidFill>
-                <a:latin typeface="Noto Sans"/>
-                <a:ea typeface="Noto Sans CJK JP"/>
-                <a:cs typeface="Noto Sans"/>
-              </a:rPr>
-              <a:t>[1] LaVi Lab, CLEVA. 公式README・ローカル評価・参照結果・利用条件。</a:t>
-            </a:r>
-            <a:r>
-              <a:rPr sz="810" b="0" lang="ja-JP" altLang="en-US">
-                <a:solidFill>
-                  <a:srgbClr val="626669"/>
-                </a:solidFill>
-                <a:latin typeface="Noto Sans"/>
-                <a:ea typeface="Noto Sans CJK JP"/>
-                <a:cs typeface="Noto Sans"/>
-              </a:rPr>
-              <a:t>  </a:t>
-            </a:r>
-            <a:r>
-              <a:rPr sz="810" b="0" lang="ja-JP" altLang="en-US">
-                <a:solidFill>
-                  <a:srgbClr val="626669"/>
-                </a:solidFill>
-                <a:latin typeface="Noto Sans"/>
-                <a:ea typeface="Noto Sans CJK JP"/>
-                <a:cs typeface="Noto Sans"/>
-                <a:hlinkClick r:id="rId2"/>
-              </a:rPr>
-              <a:t>https://github.com/LaVi-Lab/CLEVA</a:t>
             </a:r>
           </a:p>
         </p:txBody>
@@ -17438,7 +16986,7 @@
                 <a:ea typeface="Noto Sans CJK JP"/>
                 <a:cs typeface="Noto Sans"/>
               </a:rPr>
-              <a:t>HELMでの利用と公開範囲</a:t>
+              <a:t>HELMを使った評価とデータの入手</a:t>
             </a:r>
           </a:p>
         </p:txBody>
@@ -17486,7 +17034,7 @@
                 <a:ea typeface="Noto Sans CJK JP"/>
                 <a:cs typeface="Noto Sans"/>
               </a:rPr>
-              <a:t>4. HELMでの利用と公開範囲</a:t>
+              <a:t>4. HELMを使った評価とデータの入手</a:t>
             </a:r>
           </a:p>
         </p:txBody>
@@ -17605,7 +17153,7 @@
                 <a:ea typeface="Noto Sans CJK JP"/>
                 <a:cs typeface="Noto Sans"/>
               </a:rPr>
-              <a:t>2023年11月、CLEVAのデータ形式・プロンプト・摂動・中国語の指標がHELMへ統合された。</a:t>
+              <a:t>2023年11月、CLEVAのデータ形式・プロンプト・入力を変える処理・中国語の指標が、HELMへ統合された。</a:t>
             </a:r>
           </a:p>
           <a:p>
@@ -17635,37 +17183,7 @@
                 <a:ea typeface="Noto Sans CJK JP"/>
                 <a:cs typeface="Noto Sans"/>
               </a:rPr>
-              <a:t>v1の設定では、課題・下位課題・プロンプトIDを指定する。選択問題と生成課題で入力の整形や回答の処理が変わる。</a:t>
-            </a:r>
-          </a:p>
-          <a:p>
-            <a:pPr marL="457200" indent="-355600">
-              <a:lnSpc>
-                <a:spcPts val="2618"/>
-              </a:lnSpc>
-              <a:spcAft>
-                <a:spcPts val="0"/>
-              </a:spcAft>
-              <a:buSzPct val="60455"/>
-              <a:buFont typeface="Noto Sans CJK JP"/>
-              <a:buChar char="●"/>
-              <a:defRPr sz="2200" b="0">
-                <a:solidFill>
-                  <a:srgbClr val="303437"/>
-                </a:solidFill>
-                <a:latin typeface="Noto Sans"/>
-              </a:defRPr>
-            </a:pPr>
-            <a:r>
-              <a:rPr sz="2200" b="0" lang="ja-JP" altLang="en-US">
-                <a:solidFill>
-                  <a:srgbClr val="303437"/>
-                </a:solidFill>
-                <a:latin typeface="Noto Sans"/>
-                <a:ea typeface="Noto Sans CJK JP"/>
-                <a:cs typeface="Noto Sans"/>
-              </a:rPr>
-              <a:t>v0.4.0のClassic公開run索引にはCLEVAの実行結果がなく、公式READMEの参照値が別に公表されている。</a:t>
+              <a:t>課題・下位課題・プロンプトを選ぶと、選択問題や文章生成に合わせて入力を整形し、回答を処理する。公式READMEでは、HELMを使ったローカル評価の方法と参照結果を公開している。</a:t>
             </a:r>
           </a:p>
         </p:txBody>
@@ -17713,7 +17231,7 @@
                 <a:ea typeface="Noto Sans CJK JP"/>
                 <a:cs typeface="Noto Sans"/>
               </a:rPr>
-              <a:t>4. HELMでの利用と公開範囲</a:t>
+              <a:t>4. HELMを使った評価とデータの入手</a:t>
             </a:r>
           </a:p>
         </p:txBody>
@@ -17767,22 +17285,8 @@
                 <a:ea typeface="Noto Sans CJK JP"/>
                 <a:cs typeface="Noto Sans"/>
               </a:rPr>
-              <a:t>[1] Stanford CRFM, HELM v0.4.0. CLEVA scenario / Converter.</a:t>
-            </a:r>
-          </a:p>
-          <a:p>
-            <a:pPr>
-              <a:lnSpc>
-                <a:spcPts val="940"/>
-              </a:lnSpc>
-              <a:buNone/>
-              <a:defRPr sz="810" b="0">
-                <a:solidFill>
-                  <a:srgbClr val="303437"/>
-                </a:solidFill>
-                <a:latin typeface="Noto Sans"/>
-              </a:defRPr>
-            </a:pPr>
+              <a:t>[1] Stanford CRFM (2023). HELM: CLEVA scenario.</a:t>
+            </a:r>
             <a:r>
               <a:rPr sz="810" b="0" lang="ja-JP" altLang="en-US">
                 <a:solidFill>
@@ -17791,917 +17295,20 @@
                 <a:latin typeface="Noto Sans"/>
                 <a:ea typeface="Noto Sans CJK JP"/>
                 <a:cs typeface="Noto Sans"/>
+              </a:rPr>
+              <a:t>  </a:t>
+            </a:r>
+            <a:r>
+              <a:rPr sz="810" b="0" lang="ja-JP" altLang="en-US">
+                <a:solidFill>
+                  <a:srgbClr val="626669"/>
+                </a:solidFill>
+                <a:latin typeface="Noto Sans"/>
+                <a:ea typeface="Noto Sans CJK JP"/>
+                <a:cs typeface="Noto Sans"/>
                 <a:hlinkClick r:id="rId2"/>
               </a:rPr>
               <a:t>https://github.com/stanford-crfm/helm/blob/v0.4.0/src/helm/benchmark/scenarios/cleva_scenario.py</a:t>
-            </a:r>
-          </a:p>
-        </p:txBody>
-      </p:sp>
-    </p:spTree>
-  </p:cSld>
-  <p:clrMapOvr>
-    <a:masterClrMapping/>
-  </p:clrMapOvr>
-</p:sld>
-</file>
-
-<file path=ppt/slides/slide33.xml><?xml version="1.0" encoding="utf-8"?>
-<p:sld xmlns:a="http://schemas.openxmlformats.org/drawingml/2006/main" xmlns:p="http://schemas.openxmlformats.org/presentationml/2006/main" xmlns:r="http://schemas.openxmlformats.org/officeDocument/2006/relationships">
-  <p:cSld>
-    <p:spTree>
-      <p:nvGrpSpPr>
-        <p:cNvPr id="1" name=""/>
-        <p:cNvGrpSpPr/>
-        <p:nvPr/>
-      </p:nvGrpSpPr>
-      <p:grpSpPr/>
-      <p:sp>
-        <p:nvSpPr>
-          <p:cNvPr id="2" name="Title 1"/>
-          <p:cNvSpPr>
-            <a:spLocks noGrp="1"/>
-          </p:cNvSpPr>
-          <p:nvPr>
-            <p:ph type="title"/>
-          </p:nvPr>
-        </p:nvSpPr>
-        <p:spPr>
-          <a:xfrm>
-            <a:off x="468172" y="650138"/>
-            <a:ext cx="8206740" cy="616305"/>
-          </a:xfrm>
-        </p:spPr>
-        <p:txBody>
-          <a:bodyPr wrap="square" lIns="0" rIns="0" tIns="0" bIns="0">
-            <a:noAutofit/>
-          </a:bodyPr>
-          <a:lstStyle/>
-          <a:p>
-            <a:pPr algn="l">
-              <a:lnSpc>
-                <a:spcPct val="110000"/>
-              </a:lnSpc>
-              <a:buNone/>
-              <a:defRPr sz="2800" b="0">
-                <a:solidFill>
-                  <a:srgbClr val="303437"/>
-                </a:solidFill>
-                <a:latin typeface="Noto Sans"/>
-              </a:defRPr>
-            </a:pPr>
-            <a:r>
-              <a:rPr sz="2800" b="1" lang="ja-JP" altLang="en-US">
-                <a:solidFill>
-                  <a:srgbClr val="303437"/>
-                </a:solidFill>
-                <a:latin typeface="Noto Sans"/>
-                <a:ea typeface="Noto Sans CJK JP"/>
-                <a:cs typeface="Noto Sans"/>
-              </a:rPr>
-              <a:t>設定ファイルと、論文の規模は別の単位</a:t>
-            </a:r>
-          </a:p>
-        </p:txBody>
-      </p:sp>
-      <p:sp>
-        <p:nvSpPr>
-          <p:cNvPr id="3" name="Title 2"/>
-          <p:cNvSpPr>
-            <a:spLocks noGrp="1"/>
-          </p:cNvSpPr>
-          <p:nvPr>
-            <p:ph type="title" idx="2"/>
-          </p:nvPr>
-        </p:nvSpPr>
-        <p:spPr>
-          <a:xfrm>
-            <a:off x="75895" y="0"/>
-            <a:ext cx="8115300" cy="480060"/>
-          </a:xfrm>
-        </p:spPr>
-        <p:txBody>
-          <a:bodyPr wrap="square" lIns="0" rIns="0" tIns="0" bIns="0" anchor="ctr">
-            <a:noAutofit/>
-          </a:bodyPr>
-          <a:lstStyle/>
-          <a:p>
-            <a:pPr algn="l">
-              <a:lnSpc>
-                <a:spcPct val="110000"/>
-              </a:lnSpc>
-              <a:buNone/>
-              <a:defRPr sz="1400" b="0">
-                <a:solidFill>
-                  <a:srgbClr val="303437"/>
-                </a:solidFill>
-                <a:latin typeface="Noto Sans"/>
-              </a:defRPr>
-            </a:pPr>
-            <a:r>
-              <a:rPr sz="1400" b="1" lang="ja-JP" altLang="en-US">
-                <a:solidFill>
-                  <a:srgbClr val="FFFEF8"/>
-                </a:solidFill>
-                <a:latin typeface="Noto Sans"/>
-                <a:ea typeface="Noto Sans CJK JP"/>
-                <a:cs typeface="Noto Sans"/>
-              </a:rPr>
-              <a:t>4. HELMでの利用と公開範囲</a:t>
-            </a:r>
-          </a:p>
-        </p:txBody>
-      </p:sp>
-      <p:graphicFrame>
-        <p:nvGraphicFramePr>
-          <p:cNvPr id="4" name="Table 3"/>
-          <p:cNvGraphicFramePr>
-            <a:graphicFrameLocks noGrp="1"/>
-          </p:cNvGraphicFramePr>
-          <p:nvPr/>
-        </p:nvGraphicFramePr>
-        <p:xfrm>
-          <a:off x="548640" y="1508760"/>
-          <a:ext cx="8046720" cy="2523744"/>
-        </p:xfrm>
-        <a:graphic>
-          <a:graphicData uri="http://schemas.openxmlformats.org/drawingml/2006/table">
-            <a:tbl>
-              <a:tblPr firstRow="0" bandRow="0"/>
-              <a:tblGrid>
-                <a:gridCol w="5303520"/>
-                <a:gridCol w="2743200"/>
-              </a:tblGrid>
-              <a:tr h="420624">
-                <a:tc>
-                  <a:txBody>
-                    <a:bodyPr wrap="square">
-                      <a:noAutofit/>
-                    </a:bodyPr>
-                    <a:lstStyle/>
-                    <a:p>
-                      <a:pPr algn="l">
-                        <a:lnSpc>
-                          <a:spcPts val="2070"/>
-                        </a:lnSpc>
-                        <a:buNone/>
-                        <a:defRPr sz="1800" b="0">
-                          <a:solidFill>
-                            <a:srgbClr val="303437"/>
-                          </a:solidFill>
-                          <a:latin typeface="Noto Sans"/>
-                        </a:defRPr>
-                      </a:pPr>
-                      <a:r>
-                        <a:rPr sz="1800" b="0" lang="ja-JP" altLang="en-US">
-                          <a:solidFill>
-                            <a:srgbClr val="303437"/>
-                          </a:solidFill>
-                          <a:latin typeface="Noto Sans"/>
-                          <a:ea typeface="Noto Sans CJK JP"/>
-                          <a:cs typeface="Noto Sans"/>
-                        </a:rPr>
-                        <a:t>対象</a:t>
-                      </a:r>
-                    </a:p>
-                  </a:txBody>
-                  <a:tcPr marL="63500" marR="63500" marT="38100" marB="38100" anchor="ctr">
-                    <a:lnL w="7620">
-                      <a:noFill/>
-                    </a:lnL>
-                    <a:lnR w="7620">
-                      <a:noFill/>
-                    </a:lnR>
-                    <a:lnT w="15240">
-                      <a:solidFill>
-                        <a:srgbClr val="626669"/>
-                      </a:solidFill>
-                      <a:prstDash val="solid"/>
-                    </a:lnT>
-                    <a:lnB w="7620">
-                      <a:solidFill>
-                        <a:srgbClr val="626669"/>
-                      </a:solidFill>
-                      <a:prstDash val="solid"/>
-                    </a:lnB>
-                    <a:solidFill>
-                      <a:srgbClr val="FFFEF8"/>
-                    </a:solidFill>
-                  </a:tcPr>
-                </a:tc>
-                <a:tc>
-                  <a:txBody>
-                    <a:bodyPr wrap="square">
-                      <a:noAutofit/>
-                    </a:bodyPr>
-                    <a:lstStyle/>
-                    <a:p>
-                      <a:pPr algn="l">
-                        <a:lnSpc>
-                          <a:spcPts val="2070"/>
-                        </a:lnSpc>
-                        <a:buNone/>
-                        <a:defRPr sz="1800" b="0">
-                          <a:solidFill>
-                            <a:srgbClr val="303437"/>
-                          </a:solidFill>
-                          <a:latin typeface="Noto Sans"/>
-                        </a:defRPr>
-                      </a:pPr>
-                      <a:r>
-                        <a:rPr sz="1800" b="0" lang="ja-JP" altLang="en-US">
-                          <a:solidFill>
-                            <a:srgbClr val="303437"/>
-                          </a:solidFill>
-                          <a:latin typeface="Noto Sans"/>
-                          <a:ea typeface="Noto Sans CJK JP"/>
-                          <a:cs typeface="Noto Sans"/>
-                        </a:rPr>
-                        <a:t>確認できる数</a:t>
-                      </a:r>
-                    </a:p>
-                  </a:txBody>
-                  <a:tcPr marL="63500" marR="63500" marT="38100" marB="38100" anchor="ctr">
-                    <a:lnL w="7620">
-                      <a:noFill/>
-                    </a:lnL>
-                    <a:lnR w="7620">
-                      <a:noFill/>
-                    </a:lnR>
-                    <a:lnT w="15240">
-                      <a:solidFill>
-                        <a:srgbClr val="626669"/>
-                      </a:solidFill>
-                      <a:prstDash val="solid"/>
-                    </a:lnT>
-                    <a:lnB w="7620">
-                      <a:solidFill>
-                        <a:srgbClr val="626669"/>
-                      </a:solidFill>
-                      <a:prstDash val="solid"/>
-                    </a:lnB>
-                    <a:solidFill>
-                      <a:srgbClr val="FFFEF8"/>
-                    </a:solidFill>
-                  </a:tcPr>
-                </a:tc>
-              </a:tr>
-              <a:tr h="420624">
-                <a:tc>
-                  <a:txBody>
-                    <a:bodyPr wrap="square">
-                      <a:noAutofit/>
-                    </a:bodyPr>
-                    <a:lstStyle/>
-                    <a:p>
-                      <a:pPr algn="l">
-                        <a:lnSpc>
-                          <a:spcPts val="2070"/>
-                        </a:lnSpc>
-                        <a:buNone/>
-                        <a:defRPr sz="1800" b="0">
-                          <a:solidFill>
-                            <a:srgbClr val="303437"/>
-                          </a:solidFill>
-                          <a:latin typeface="Noto Sans"/>
-                        </a:defRPr>
-                      </a:pPr>
-                      <a:r>
-                        <a:rPr sz="1800" b="0" lang="ja-JP" altLang="en-US">
-                          <a:solidFill>
-                            <a:srgbClr val="303437"/>
-                          </a:solidFill>
-                          <a:latin typeface="Noto Sans"/>
-                          <a:ea typeface="Noto Sans CJK JP"/>
-                          <a:cs typeface="Noto Sans"/>
-                        </a:rPr>
-                        <a:t>論文の課題</a:t>
-                      </a:r>
-                    </a:p>
-                  </a:txBody>
-                  <a:tcPr marL="63500" marR="63500" marT="38100" marB="38100" anchor="ctr">
-                    <a:lnL w="7620">
-                      <a:noFill/>
-                    </a:lnL>
-                    <a:lnR w="7620">
-                      <a:noFill/>
-                    </a:lnR>
-                    <a:lnT w="7620">
-                      <a:solidFill>
-                        <a:srgbClr val="626669"/>
-                      </a:solidFill>
-                      <a:prstDash val="solid"/>
-                    </a:lnT>
-                    <a:lnB w="7620">
-                      <a:noFill/>
-                    </a:lnB>
-                    <a:solidFill>
-                      <a:srgbClr val="FFFEF8"/>
-                    </a:solidFill>
-                  </a:tcPr>
-                </a:tc>
-                <a:tc>
-                  <a:txBody>
-                    <a:bodyPr wrap="square">
-                      <a:noAutofit/>
-                    </a:bodyPr>
-                    <a:lstStyle/>
-                    <a:p>
-                      <a:pPr algn="l">
-                        <a:lnSpc>
-                          <a:spcPts val="2070"/>
-                        </a:lnSpc>
-                        <a:buNone/>
-                        <a:defRPr sz="1800" b="0">
-                          <a:solidFill>
-                            <a:srgbClr val="303437"/>
-                          </a:solidFill>
-                          <a:latin typeface="Noto Sans"/>
-                        </a:defRPr>
-                      </a:pPr>
-                      <a:r>
-                        <a:rPr sz="1800" b="0" lang="ja-JP" altLang="en-US">
-                          <a:solidFill>
-                            <a:srgbClr val="303437"/>
-                          </a:solidFill>
-                          <a:latin typeface="Noto Sans"/>
-                          <a:ea typeface="Noto Sans CJK JP"/>
-                          <a:cs typeface="Noto Sans"/>
-                        </a:rPr>
-                        <a:t>31</a:t>
-                      </a:r>
-                    </a:p>
-                  </a:txBody>
-                  <a:tcPr marL="63500" marR="63500" marT="38100" marB="38100" anchor="ctr">
-                    <a:lnL w="7620">
-                      <a:noFill/>
-                    </a:lnL>
-                    <a:lnR w="7620">
-                      <a:noFill/>
-                    </a:lnR>
-                    <a:lnT w="7620">
-                      <a:solidFill>
-                        <a:srgbClr val="626669"/>
-                      </a:solidFill>
-                      <a:prstDash val="solid"/>
-                    </a:lnT>
-                    <a:lnB w="7620">
-                      <a:noFill/>
-                    </a:lnB>
-                    <a:solidFill>
-                      <a:srgbClr val="FFFEF8"/>
-                    </a:solidFill>
-                  </a:tcPr>
-                </a:tc>
-              </a:tr>
-              <a:tr h="420624">
-                <a:tc>
-                  <a:txBody>
-                    <a:bodyPr wrap="square">
-                      <a:noAutofit/>
-                    </a:bodyPr>
-                    <a:lstStyle/>
-                    <a:p>
-                      <a:pPr algn="l">
-                        <a:lnSpc>
-                          <a:spcPts val="2070"/>
-                        </a:lnSpc>
-                        <a:buNone/>
-                        <a:defRPr sz="1800" b="0">
-                          <a:solidFill>
-                            <a:srgbClr val="303437"/>
-                          </a:solidFill>
-                          <a:latin typeface="Noto Sans"/>
-                        </a:defRPr>
-                      </a:pPr>
-                      <a:r>
-                        <a:rPr sz="1800" b="0" lang="ja-JP" altLang="en-US">
-                          <a:solidFill>
-                            <a:srgbClr val="303437"/>
-                          </a:solidFill>
-                          <a:latin typeface="Noto Sans"/>
-                          <a:ea typeface="Noto Sans CJK JP"/>
-                          <a:cs typeface="Noto Sans"/>
-                        </a:rPr>
-                        <a:t>v0.4.0設定の課題</a:t>
-                      </a:r>
-                    </a:p>
-                  </a:txBody>
-                  <a:tcPr marL="63500" marR="63500" marT="38100" marB="38100" anchor="ctr">
-                    <a:lnL w="7620">
-                      <a:noFill/>
-                    </a:lnL>
-                    <a:lnR w="7620">
-                      <a:noFill/>
-                    </a:lnR>
-                    <a:lnT w="7620">
-                      <a:noFill/>
-                    </a:lnT>
-                    <a:lnB w="7620">
-                      <a:noFill/>
-                    </a:lnB>
-                    <a:solidFill>
-                      <a:srgbClr val="FFFEF8"/>
-                    </a:solidFill>
-                  </a:tcPr>
-                </a:tc>
-                <a:tc>
-                  <a:txBody>
-                    <a:bodyPr wrap="square">
-                      <a:noAutofit/>
-                    </a:bodyPr>
-                    <a:lstStyle/>
-                    <a:p>
-                      <a:pPr algn="l">
-                        <a:lnSpc>
-                          <a:spcPts val="2070"/>
-                        </a:lnSpc>
-                        <a:buNone/>
-                        <a:defRPr sz="1800" b="0">
-                          <a:solidFill>
-                            <a:srgbClr val="303437"/>
-                          </a:solidFill>
-                          <a:latin typeface="Noto Sans"/>
-                        </a:defRPr>
-                      </a:pPr>
-                      <a:r>
-                        <a:rPr sz="1800" b="0" lang="ja-JP" altLang="en-US">
-                          <a:solidFill>
-                            <a:srgbClr val="303437"/>
-                          </a:solidFill>
-                          <a:latin typeface="Noto Sans"/>
-                          <a:ea typeface="Noto Sans CJK JP"/>
-                          <a:cs typeface="Noto Sans"/>
-                        </a:rPr>
-                        <a:t>31</a:t>
-                      </a:r>
-                    </a:p>
-                  </a:txBody>
-                  <a:tcPr marL="63500" marR="63500" marT="38100" marB="38100" anchor="ctr">
-                    <a:lnL w="7620">
-                      <a:noFill/>
-                    </a:lnL>
-                    <a:lnR w="7620">
-                      <a:noFill/>
-                    </a:lnR>
-                    <a:lnT w="7620">
-                      <a:noFill/>
-                    </a:lnT>
-                    <a:lnB w="7620">
-                      <a:noFill/>
-                    </a:lnB>
-                    <a:solidFill>
-                      <a:srgbClr val="FFFEF8"/>
-                    </a:solidFill>
-                  </a:tcPr>
-                </a:tc>
-              </a:tr>
-              <a:tr h="420624">
-                <a:tc>
-                  <a:txBody>
-                    <a:bodyPr wrap="square">
-                      <a:noAutofit/>
-                    </a:bodyPr>
-                    <a:lstStyle/>
-                    <a:p>
-                      <a:pPr algn="l">
-                        <a:lnSpc>
-                          <a:spcPts val="2070"/>
-                        </a:lnSpc>
-                        <a:buNone/>
-                        <a:defRPr sz="1800" b="0">
-                          <a:solidFill>
-                            <a:srgbClr val="303437"/>
-                          </a:solidFill>
-                          <a:latin typeface="Noto Sans"/>
-                        </a:defRPr>
-                      </a:pPr>
-                      <a:r>
-                        <a:rPr sz="1800" b="0" lang="ja-JP" altLang="en-US">
-                          <a:solidFill>
-                            <a:srgbClr val="303437"/>
-                          </a:solidFill>
-                          <a:latin typeface="Noto Sans"/>
-                          <a:ea typeface="Noto Sans CJK JP"/>
-                          <a:cs typeface="Noto Sans"/>
-                        </a:rPr>
-                        <a:t>設定の課題×下位課題</a:t>
-                      </a:r>
-                    </a:p>
-                  </a:txBody>
-                  <a:tcPr marL="63500" marR="63500" marT="38100" marB="38100" anchor="ctr">
-                    <a:lnL w="7620">
-                      <a:noFill/>
-                    </a:lnL>
-                    <a:lnR w="7620">
-                      <a:noFill/>
-                    </a:lnR>
-                    <a:lnT w="7620">
-                      <a:noFill/>
-                    </a:lnT>
-                    <a:lnB w="7620">
-                      <a:noFill/>
-                    </a:lnB>
-                    <a:solidFill>
-                      <a:srgbClr val="FFFEF8"/>
-                    </a:solidFill>
-                  </a:tcPr>
-                </a:tc>
-                <a:tc>
-                  <a:txBody>
-                    <a:bodyPr wrap="square">
-                      <a:noAutofit/>
-                    </a:bodyPr>
-                    <a:lstStyle/>
-                    <a:p>
-                      <a:pPr algn="l">
-                        <a:lnSpc>
-                          <a:spcPts val="2070"/>
-                        </a:lnSpc>
-                        <a:buNone/>
-                        <a:defRPr sz="1800" b="0">
-                          <a:solidFill>
-                            <a:srgbClr val="303437"/>
-                          </a:solidFill>
-                          <a:latin typeface="Noto Sans"/>
-                        </a:defRPr>
-                      </a:pPr>
-                      <a:r>
-                        <a:rPr sz="1800" b="0" lang="ja-JP" altLang="en-US">
-                          <a:solidFill>
-                            <a:srgbClr val="303437"/>
-                          </a:solidFill>
-                          <a:latin typeface="Noto Sans"/>
-                          <a:ea typeface="Noto Sans CJK JP"/>
-                          <a:cs typeface="Noto Sans"/>
-                        </a:rPr>
-                        <a:t>65組</a:t>
-                      </a:r>
-                    </a:p>
-                  </a:txBody>
-                  <a:tcPr marL="63500" marR="63500" marT="38100" marB="38100" anchor="ctr">
-                    <a:lnL w="7620">
-                      <a:noFill/>
-                    </a:lnL>
-                    <a:lnR w="7620">
-                      <a:noFill/>
-                    </a:lnR>
-                    <a:lnT w="7620">
-                      <a:noFill/>
-                    </a:lnT>
-                    <a:lnB w="7620">
-                      <a:noFill/>
-                    </a:lnB>
-                    <a:solidFill>
-                      <a:srgbClr val="FFFEF8"/>
-                    </a:solidFill>
-                  </a:tcPr>
-                </a:tc>
-              </a:tr>
-              <a:tr h="420624">
-                <a:tc>
-                  <a:txBody>
-                    <a:bodyPr wrap="square">
-                      <a:noAutofit/>
-                    </a:bodyPr>
-                    <a:lstStyle/>
-                    <a:p>
-                      <a:pPr algn="l">
-                        <a:lnSpc>
-                          <a:spcPts val="2070"/>
-                        </a:lnSpc>
-                        <a:buNone/>
-                        <a:defRPr sz="1800" b="0">
-                          <a:solidFill>
-                            <a:srgbClr val="303437"/>
-                          </a:solidFill>
-                          <a:latin typeface="Noto Sans"/>
-                        </a:defRPr>
-                      </a:pPr>
-                      <a:r>
-                        <a:rPr sz="1800" b="0" lang="ja-JP" altLang="en-US">
-                          <a:solidFill>
-                            <a:srgbClr val="303437"/>
-                          </a:solidFill>
-                          <a:latin typeface="Noto Sans"/>
-                          <a:ea typeface="Noto Sans CJK JP"/>
-                          <a:cs typeface="Noto Sans"/>
-                        </a:rPr>
-                        <a:t>設定のプロンプト記述</a:t>
-                      </a:r>
-                    </a:p>
-                  </a:txBody>
-                  <a:tcPr marL="63500" marR="63500" marT="38100" marB="38100" anchor="ctr">
-                    <a:lnL w="7620">
-                      <a:noFill/>
-                    </a:lnL>
-                    <a:lnR w="7620">
-                      <a:noFill/>
-                    </a:lnR>
-                    <a:lnT w="7620">
-                      <a:noFill/>
-                    </a:lnT>
-                    <a:lnB w="7620">
-                      <a:noFill/>
-                    </a:lnB>
-                    <a:solidFill>
-                      <a:srgbClr val="FFFEF8"/>
-                    </a:solidFill>
-                  </a:tcPr>
-                </a:tc>
-                <a:tc>
-                  <a:txBody>
-                    <a:bodyPr wrap="square">
-                      <a:noAutofit/>
-                    </a:bodyPr>
-                    <a:lstStyle/>
-                    <a:p>
-                      <a:pPr algn="l">
-                        <a:lnSpc>
-                          <a:spcPts val="2070"/>
-                        </a:lnSpc>
-                        <a:buNone/>
-                        <a:defRPr sz="1800" b="0">
-                          <a:solidFill>
-                            <a:srgbClr val="303437"/>
-                          </a:solidFill>
-                          <a:latin typeface="Noto Sans"/>
-                        </a:defRPr>
-                      </a:pPr>
-                      <a:r>
-                        <a:rPr sz="1800" b="0" lang="ja-JP" altLang="en-US">
-                          <a:solidFill>
-                            <a:srgbClr val="303437"/>
-                          </a:solidFill>
-                          <a:latin typeface="Noto Sans"/>
-                          <a:ea typeface="Noto Sans CJK JP"/>
-                          <a:cs typeface="Noto Sans"/>
-                        </a:rPr>
-                        <a:t>253項目</a:t>
-                      </a:r>
-                    </a:p>
-                  </a:txBody>
-                  <a:tcPr marL="63500" marR="63500" marT="38100" marB="38100" anchor="ctr">
-                    <a:lnL w="7620">
-                      <a:noFill/>
-                    </a:lnL>
-                    <a:lnR w="7620">
-                      <a:noFill/>
-                    </a:lnR>
-                    <a:lnT w="7620">
-                      <a:noFill/>
-                    </a:lnT>
-                    <a:lnB w="7620">
-                      <a:noFill/>
-                    </a:lnB>
-                    <a:solidFill>
-                      <a:srgbClr val="FFFEF8"/>
-                    </a:solidFill>
-                  </a:tcPr>
-                </a:tc>
-              </a:tr>
-              <a:tr h="420624">
-                <a:tc>
-                  <a:txBody>
-                    <a:bodyPr wrap="square">
-                      <a:noAutofit/>
-                    </a:bodyPr>
-                    <a:lstStyle/>
-                    <a:p>
-                      <a:pPr algn="l">
-                        <a:lnSpc>
-                          <a:spcPts val="2070"/>
-                        </a:lnSpc>
-                        <a:buNone/>
-                        <a:defRPr sz="1800" b="0">
-                          <a:solidFill>
-                            <a:srgbClr val="303437"/>
-                          </a:solidFill>
-                          <a:latin typeface="Noto Sans"/>
-                        </a:defRPr>
-                      </a:pPr>
-                      <a:r>
-                        <a:rPr sz="1800" b="0" lang="ja-JP" altLang="en-US">
-                          <a:solidFill>
-                            <a:srgbClr val="303437"/>
-                          </a:solidFill>
-                          <a:latin typeface="Noto Sans"/>
-                          <a:ea typeface="Noto Sans CJK JP"/>
-                          <a:cs typeface="Noto Sans"/>
-                        </a:rPr>
-                        <a:t>Classic公開run索引のCLEVA</a:t>
-                      </a:r>
-                    </a:p>
-                  </a:txBody>
-                  <a:tcPr marL="63500" marR="63500" marT="38100" marB="38100" anchor="ctr">
-                    <a:lnL w="7620">
-                      <a:noFill/>
-                    </a:lnL>
-                    <a:lnR w="7620">
-                      <a:noFill/>
-                    </a:lnR>
-                    <a:lnT w="7620">
-                      <a:noFill/>
-                    </a:lnT>
-                    <a:lnB w="15240">
-                      <a:solidFill>
-                        <a:srgbClr val="626669"/>
-                      </a:solidFill>
-                      <a:prstDash val="solid"/>
-                    </a:lnB>
-                    <a:solidFill>
-                      <a:srgbClr val="FFFEF8"/>
-                    </a:solidFill>
-                  </a:tcPr>
-                </a:tc>
-                <a:tc>
-                  <a:txBody>
-                    <a:bodyPr wrap="square">
-                      <a:noAutofit/>
-                    </a:bodyPr>
-                    <a:lstStyle/>
-                    <a:p>
-                      <a:pPr algn="l">
-                        <a:lnSpc>
-                          <a:spcPts val="2070"/>
-                        </a:lnSpc>
-                        <a:buNone/>
-                        <a:defRPr sz="1800" b="0">
-                          <a:solidFill>
-                            <a:srgbClr val="303437"/>
-                          </a:solidFill>
-                          <a:latin typeface="Noto Sans"/>
-                        </a:defRPr>
-                      </a:pPr>
-                      <a:r>
-                        <a:rPr sz="1800" b="0" lang="ja-JP" altLang="en-US">
-                          <a:solidFill>
-                            <a:srgbClr val="303437"/>
-                          </a:solidFill>
-                          <a:latin typeface="Noto Sans"/>
-                          <a:ea typeface="Noto Sans CJK JP"/>
-                          <a:cs typeface="Noto Sans"/>
-                        </a:rPr>
-                        <a:t>0件</a:t>
-                      </a:r>
-                    </a:p>
-                  </a:txBody>
-                  <a:tcPr marL="63500" marR="63500" marT="38100" marB="38100" anchor="ctr">
-                    <a:lnL w="7620">
-                      <a:noFill/>
-                    </a:lnL>
-                    <a:lnR w="7620">
-                      <a:noFill/>
-                    </a:lnR>
-                    <a:lnT w="7620">
-                      <a:noFill/>
-                    </a:lnT>
-                    <a:lnB w="15240">
-                      <a:solidFill>
-                        <a:srgbClr val="626669"/>
-                      </a:solidFill>
-                      <a:prstDash val="solid"/>
-                    </a:lnB>
-                    <a:solidFill>
-                      <a:srgbClr val="FFFEF8"/>
-                    </a:solidFill>
-                  </a:tcPr>
-                </a:tc>
-              </a:tr>
-            </a:tbl>
-          </a:graphicData>
-        </a:graphic>
-      </p:graphicFrame>
-      <p:sp>
-        <p:nvSpPr>
-          <p:cNvPr id="5" name="TextBox 4"/>
-          <p:cNvSpPr txBox="1"/>
-          <p:nvPr/>
-        </p:nvSpPr>
-        <p:spPr>
-          <a:xfrm>
-            <a:off x="594360" y="4233672"/>
-            <a:ext cx="7955279" cy="658368"/>
-          </a:xfrm>
-          <a:prstGeom prst="rect">
-            <a:avLst/>
-          </a:prstGeom>
-          <a:noFill/>
-        </p:spPr>
-        <p:txBody>
-          <a:bodyPr wrap="square" lIns="0" rIns="0" tIns="0" bIns="0">
-            <a:noAutofit/>
-          </a:bodyPr>
-          <a:lstStyle/>
-          <a:p>
-            <a:pPr algn="l">
-              <a:lnSpc>
-                <a:spcPts val="2047"/>
-              </a:lnSpc>
-              <a:spcBef>
-                <a:spcPts val="0"/>
-              </a:spcBef>
-              <a:spcAft>
-                <a:spcPts val="0"/>
-              </a:spcAft>
-              <a:buNone/>
-              <a:defRPr sz="1750" b="0">
-                <a:solidFill>
-                  <a:srgbClr val="303437"/>
-                </a:solidFill>
-                <a:latin typeface="Noto Sans"/>
-              </a:defRPr>
-            </a:pPr>
-            <a:r>
-              <a:rPr sz="1750" b="0" lang="ja-JP" altLang="en-US">
-                <a:solidFill>
-                  <a:srgbClr val="303437"/>
-                </a:solidFill>
-                <a:latin typeface="Noto Sans"/>
-                <a:ea typeface="Noto Sans CJK JP"/>
-                <a:cs typeface="Noto Sans"/>
-              </a:rPr>
-              <a:t>設定の組合せ・プロンプト数と、収録データセット数は別の単位。</a:t>
-            </a:r>
-          </a:p>
-        </p:txBody>
-      </p:sp>
-      <p:sp>
-        <p:nvSpPr>
-          <p:cNvPr id="6" name="sources"/>
-          <p:cNvSpPr txBox="1"/>
-          <p:nvPr/>
-        </p:nvSpPr>
-        <p:spPr>
-          <a:xfrm>
-            <a:off x="502920" y="4700016"/>
-            <a:ext cx="8183879" cy="530352"/>
-          </a:xfrm>
-          <a:prstGeom prst="rect">
-            <a:avLst/>
-          </a:prstGeom>
-          <a:noFill/>
-        </p:spPr>
-        <p:txBody>
-          <a:bodyPr wrap="square" lIns="0" rIns="0" tIns="0" bIns="0">
-            <a:noAutofit/>
-          </a:bodyPr>
-          <a:lstStyle/>
-          <a:p>
-            <a:pPr algn="l">
-              <a:lnSpc>
-                <a:spcPts val="940"/>
-              </a:lnSpc>
-              <a:spcBef>
-                <a:spcPts val="0"/>
-              </a:spcBef>
-              <a:spcAft>
-                <a:spcPts val="140"/>
-              </a:spcAft>
-              <a:buNone/>
-              <a:defRPr sz="810" b="0">
-                <a:solidFill>
-                  <a:srgbClr val="303437"/>
-                </a:solidFill>
-                <a:latin typeface="Noto Sans"/>
-              </a:defRPr>
-            </a:pPr>
-            <a:r>
-              <a:rPr sz="810" b="0" lang="ja-JP" altLang="en-US">
-                <a:solidFill>
-                  <a:srgbClr val="626669"/>
-                </a:solidFill>
-                <a:latin typeface="Noto Sans"/>
-                <a:ea typeface="Noto Sans CJK JP"/>
-                <a:cs typeface="Noto Sans"/>
-              </a:rPr>
-              <a:t>[1] Stanford CRFM, HELM v0.4.0. CLEVA v1 run configuration.</a:t>
-            </a:r>
-          </a:p>
-          <a:p>
-            <a:pPr>
-              <a:lnSpc>
-                <a:spcPts val="940"/>
-              </a:lnSpc>
-              <a:buNone/>
-              <a:defRPr sz="810" b="0">
-                <a:solidFill>
-                  <a:srgbClr val="303437"/>
-                </a:solidFill>
-                <a:latin typeface="Noto Sans"/>
-              </a:defRPr>
-            </a:pPr>
-            <a:r>
-              <a:rPr sz="810" b="0" lang="ja-JP" altLang="en-US">
-                <a:solidFill>
-                  <a:srgbClr val="626669"/>
-                </a:solidFill>
-                <a:latin typeface="Noto Sans"/>
-                <a:ea typeface="Noto Sans CJK JP"/>
-                <a:cs typeface="Noto Sans"/>
-                <a:hlinkClick r:id="rId2"/>
-              </a:rPr>
-              <a:t>https://github.com/stanford-crfm/helm/blob/v0.4.0/src/helm/benchmark/presentation/run_specs_cleva_v1.conf</a:t>
             </a:r>
           </a:p>
         </p:txBody>
@@ -18767,7 +17374,7 @@
                 <a:ea typeface="Noto Sans CJK JP"/>
                 <a:cs typeface="Noto Sans"/>
               </a:rPr>
-              <a:t>入手先と、現在確認できる範囲</a:t>
+              <a:t>公式GitHubから、データと評価手順を探す</a:t>
             </a:r>
           </a:p>
         </p:txBody>
@@ -18820,7 +17427,7 @@
                 <a:ea typeface="Noto Sans CJK JP"/>
                 <a:cs typeface="Noto Sans"/>
               </a:rPr>
-              <a:t>公式GitHubは、CLEVA v1のダウンロード方法とHELMでの評価方法を公開している。</a:t>
+              <a:t>公式GitHubは、CLEVA v1のダウンロード先と、HELMを使った評価方法を案内している。</a:t>
             </a:r>
           </a:p>
           <a:p>
@@ -18850,37 +17457,7 @@
                 <a:ea typeface="Noto Sans CJK JP"/>
                 <a:cs typeface="Noto Sans"/>
               </a:rPr>
-              <a:t>取得時には、公式のオンライン画面とv1配布ファイルに接続できなかった。公開論文と固定実装は取得でき、説明例・入力形式・指標を確認できる。</a:t>
-            </a:r>
-          </a:p>
-          <a:p>
-            <a:pPr marL="457200" indent="-355600">
-              <a:lnSpc>
-                <a:spcPts val="2499"/>
-              </a:lnSpc>
-              <a:spcAft>
-                <a:spcPts val="0"/>
-              </a:spcAft>
-              <a:buSzPct val="63333"/>
-              <a:buFont typeface="Noto Sans CJK JP"/>
-              <a:buChar char="●"/>
-              <a:defRPr sz="2100" b="0">
-                <a:solidFill>
-                  <a:srgbClr val="303437"/>
-                </a:solidFill>
-                <a:latin typeface="Noto Sans"/>
-              </a:defRPr>
-            </a:pPr>
-            <a:r>
-              <a:rPr sz="2100" b="0" lang="ja-JP" altLang="en-US">
-                <a:solidFill>
-                  <a:srgbClr val="303437"/>
-                </a:solidFill>
-                <a:latin typeface="Noto Sans"/>
-                <a:ea typeface="Noto Sans CJK JP"/>
-                <a:cs typeface="Noto Sans"/>
-              </a:rPr>
-              <a:t>C3やMath23Kなど、採用元の公開データは別の配布元から取得できる。CLEVA v1での選定範囲、整形、分割とは区別して利用する。</a:t>
+              <a:t>CLEVA v1で使われた全問題や選定範囲は、公開論文とコードの説明だけでは確認できない。C3やMath23Kなど、採用元の公開データは各データセットの配布元からも取得できる。</a:t>
             </a:r>
           </a:p>
         </p:txBody>
@@ -18928,7 +17505,7 @@
                 <a:ea typeface="Noto Sans CJK JP"/>
                 <a:cs typeface="Noto Sans"/>
               </a:rPr>
-              <a:t>4. HELMでの利用と公開範囲</a:t>
+              <a:t>4. HELMを使った評価とデータの入手</a:t>
             </a:r>
           </a:p>
         </p:txBody>
@@ -18982,7 +17559,7 @@
                 <a:ea typeface="Noto Sans CJK JP"/>
                 <a:cs typeface="Noto Sans"/>
               </a:rPr>
-              <a:t>[1] LaVi Lab, CLEVA. 公式README・ローカル評価・参照結果・利用条件。</a:t>
+              <a:t>[1] LaVi Lab. CLEVA公式リポジトリ。</a:t>
             </a:r>
             <a:r>
               <a:rPr sz="810" b="0" lang="ja-JP" altLang="en-US">
@@ -19124,7 +17701,7 @@
                 <a:ea typeface="Noto Sans CJK JP"/>
                 <a:cs typeface="Noto Sans"/>
               </a:rPr>
-              <a:t>中国語のモデルを幅広く比べるには、どの課題で何を出力させたかをそろえる必要がある。CLEVAは、その手順と評価軸をまとめた基盤である。</a:t>
+              <a:t>CLEVAは、中国語モデルの31課題と九つの評価軸をまとめ、幅広い能力や応答の性質を調べる評価基盤である。</a:t>
             </a:r>
           </a:p>
           <a:p>
@@ -19154,37 +17731,7 @@
                 <a:ea typeface="Noto Sans CJK JP"/>
                 <a:cs typeface="Noto Sans"/>
               </a:rPr>
-              <a:t>複数プロンプトと九つの評価軸は、平均的な正しさだけでなく、変動や生成文の性質も調べるために使う。</a:t>
-            </a:r>
-          </a:p>
-          <a:p>
-            <a:pPr marL="457200" indent="-355600">
-              <a:lnSpc>
-                <a:spcPts val="2618"/>
-              </a:lnSpc>
-              <a:spcAft>
-                <a:spcPts val="0"/>
-              </a:spcAft>
-              <a:buSzPct val="60455"/>
-              <a:buFont typeface="Noto Sans CJK JP"/>
-              <a:buChar char="●"/>
-              <a:defRPr sz="2200" b="0">
-                <a:solidFill>
-                  <a:srgbClr val="303437"/>
-                </a:solidFill>
-                <a:latin typeface="Noto Sans"/>
-              </a:defRPr>
-            </a:pPr>
-            <a:r>
-              <a:rPr sz="2200" b="0" lang="ja-JP" altLang="en-US">
-                <a:solidFill>
-                  <a:srgbClr val="303437"/>
-                </a:solidFill>
-                <a:latin typeface="Noto Sans"/>
-                <a:ea typeface="Noto Sans CJK JP"/>
-                <a:cs typeface="Noto Sans"/>
-              </a:rPr>
-              <a:t>実行時点・モデル版・入力形式・参照回答・抽出集合を確かめて、比較できる範囲の結果を読む。</a:t>
+              <a:t>共通の入力形式と複数のプロンプトを使い、正答率に加えて、問い方による変動、信頼性、生成文の性質を測る。新しいデータの収集と評価集合の抽出により、学習データへの混入にも対処する。</a:t>
             </a:r>
           </a:p>
         </p:txBody>
@@ -19232,7 +17779,7 @@
                 <a:ea typeface="Noto Sans CJK JP"/>
                 <a:cs typeface="Noto Sans"/>
               </a:rPr>
-              <a:t>4. HELMでの利用と公開範囲</a:t>
+              <a:t>4. HELMを使った評価とデータの入手</a:t>
             </a:r>
           </a:p>
         </p:txBody>
@@ -19286,7 +17833,7 @@
                 <a:ea typeface="Noto Sans CJK JP"/>
                 <a:cs typeface="Noto Sans"/>
               </a:rPr>
-              <a:t>[1] Li, Zhao et al. (2023), CLEVA: Chinese Language Models EVAluation Platform. EMNLP System Demonstrations.</a:t>
+              <a:t>[1] Li et al. (2023). CLEVA. EMNLP System Demonstrations.</a:t>
             </a:r>
             <a:r>
               <a:rPr sz="810" b="0" lang="ja-JP" altLang="en-US">
@@ -19345,11 +17892,11 @@
         <p:spPr>
           <a:xfrm>
             <a:off x="548640" y="2423875"/>
-            <a:ext cx="8046720" cy="707136"/>
+            <a:ext cx="8046720" cy="808736"/>
           </a:xfrm>
         </p:spPr>
         <p:txBody>
-          <a:bodyPr wrap="square" lIns="0" rIns="0" tIns="0" bIns="0" anchor="ctr">
+          <a:bodyPr wrap="square" lIns="0" rIns="0" tIns="0" bIns="101600" anchor="ctr">
             <a:noAutofit/>
           </a:bodyPr>
           <a:lstStyle/>
@@ -19572,7 +18119,7 @@
                 <a:ea typeface="Noto Sans CJK JP"/>
                 <a:cs typeface="Noto Sans"/>
               </a:rPr>
-              <a:t>設定・統計・利用条件</a:t>
+              <a:t>課題の種類と評価の仕組み</a:t>
             </a:r>
           </a:p>
           <a:p>
@@ -20575,7 +19122,7 @@
                 <a:ea typeface="Noto Sans CJK JP"/>
                 <a:cs typeface="Noto Sans"/>
               </a:rPr>
-              <a:t>[1] Li, Zhao et al. (2023), CLEVA. 公開説明例。 公開例 A2.SS1.SSS1.Px5 ／ 古典中国語の理解。</a:t>
+              <a:t>[1] Li et al. (2023). CLEVA. 公開説明例。</a:t>
             </a:r>
             <a:r>
               <a:rPr sz="810" b="0" lang="ja-JP" altLang="en-US">
@@ -20880,7 +19427,7 @@
                 <a:ea typeface="Noto Sans CJK JP"/>
                 <a:cs typeface="Noto Sans"/>
               </a:rPr>
-              <a:t>公開説明例の原文（表示範囲を保持）</a:t>
+              <a:t>公開説明例の原文</a:t>
             </a:r>
           </a:p>
         </p:txBody>
@@ -21217,7 +19764,7 @@
                 <a:ea typeface="Noto Sans CJK JP"/>
                 <a:cs typeface="Noto Sans"/>
               </a:rPr>
-              <a:t>[1] Li, Zhao et al. (2023), CLEVA. 公開説明例。 公開例 A2.SS1.SSS2.Px2 ／ 文化的知識。</a:t>
+              <a:t>[1] Li et al. (2023). CLEVA. 公開説明例。</a:t>
             </a:r>
             <a:r>
               <a:rPr sz="810" b="0" lang="ja-JP" altLang="en-US">
@@ -21714,7 +20261,7 @@
                 <a:ea typeface="Noto Sans CJK JP"/>
                 <a:cs typeface="Noto Sans"/>
               </a:rPr>
-              <a:t>[1] Li, Zhao et al. (2023), CLEVA. 公開説明例。 公開例 A2.SS1.SSS2.Px2 ／ 文化的知識。</a:t>
+              <a:t>[1] Li et al. (2023). CLEVA. 公開説明例。</a:t>
             </a:r>
             <a:r>
               <a:rPr sz="810" b="0" lang="ja-JP" altLang="en-US">
@@ -22231,7 +20778,7 @@
                 <a:ea typeface="Noto Sans CJK JP"/>
                 <a:cs typeface="Noto Sans"/>
               </a:rPr>
-              <a:t>「かごだよ、1元、1元だよ。」という発言から、「このかごは販売されている」と推論できるか。</a:t>
+              <a:t>「かごだよ、1元、1元だよ。」という発言から、「このかごは売ることができる」と推論できるか。</a:t>
             </a:r>
           </a:p>
           <a:p>
@@ -22486,7 +21033,7 @@
                 <a:ea typeface="Noto Sans CJK JP"/>
                 <a:cs typeface="Noto Sans"/>
               </a:rPr>
-              <a:t>[1] Li, Zhao et al. (2023), CLEVA. 公開説明例。 公開例 A2.SS1.SSS3.Px2 ／ 常識推論・含意判定。</a:t>
+              <a:t>[1] Li et al. (2023). CLEVA. 公開説明例。</a:t>
             </a:r>
             <a:r>
               <a:rPr sz="810" b="0" lang="ja-JP" altLang="en-US">
@@ -23041,7 +21588,7 @@
                 <a:ea typeface="Noto Sans CJK JP"/>
                 <a:cs typeface="Noto Sans"/>
               </a:rPr>
-              <a:t>[1] Li, Zhao et al. (2023), CLEVA. 公開説明例。 公開例 A2.SS1.SSS2.Px1 ／ 分野別知識。</a:t>
+              <a:t>[1] Li et al. (2023). CLEVA. 公開説明例。</a:t>
             </a:r>
             <a:r>
               <a:rPr sz="810" b="0" lang="ja-JP" altLang="en-US">
@@ -23689,7 +22236,7 @@
                 <a:ea typeface="Noto Sans CJK JP"/>
                 <a:cs typeface="Noto Sans"/>
               </a:rPr>
-              <a:t>[1] Li, Zhao et al. (2023), CLEVA. 公開説明例。 公開例 A2.SS1.SSS4.Px4 ／ 事実確認。</a:t>
+              <a:t>[1] Li et al. (2023). CLEVA. 公開説明例。</a:t>
             </a:r>
             <a:r>
               <a:rPr sz="810" b="0" lang="ja-JP" altLang="en-US">
@@ -24337,7 +22884,7 @@
                 <a:ea typeface="Noto Sans CJK JP"/>
                 <a:cs typeface="Noto Sans"/>
               </a:rPr>
-              <a:t>[1] Li, Zhao et al. (2023), CLEVA. 公開説明例。 公開例 A2.SS2.SSS0.Px6 ／ 感情分析。</a:t>
+              <a:t>[1] Li et al. (2023). CLEVA. 公開説明例。</a:t>
             </a:r>
             <a:r>
               <a:rPr sz="810" b="0" lang="ja-JP" altLang="en-US">
@@ -24892,7 +23439,7 @@
                 <a:ea typeface="Noto Sans CJK JP"/>
                 <a:cs typeface="Noto Sans"/>
               </a:rPr>
-              <a:t>[1] Li, Zhao et al. (2023), CLEVA. 公開説明例。 公開例 A2.SS2.SSS0.Px7 ／ 文章分類。</a:t>
+              <a:t>[1] Li et al. (2023). CLEVA. 公開説明例。</a:t>
             </a:r>
             <a:r>
               <a:rPr sz="810" b="0" lang="ja-JP" altLang="en-US">
@@ -25447,7 +23994,7 @@
                 <a:ea typeface="Noto Sans CJK JP"/>
                 <a:cs typeface="Noto Sans"/>
               </a:rPr>
-              <a:t>[1] Li, Zhao et al. (2023), CLEVA. 公開説明例。 公開例 A2.SS2.SSS0.Px8 ／ 意見の対象抽出。</a:t>
+              <a:t>[1] Li et al. (2023). CLEVA. 公開説明例。</a:t>
             </a:r>
             <a:r>
               <a:rPr sz="810" b="0" lang="ja-JP" altLang="en-US">
@@ -26002,7 +24549,7 @@
                 <a:ea typeface="Noto Sans CJK JP"/>
                 <a:cs typeface="Noto Sans"/>
               </a:rPr>
-              <a:t>[1] Li, Zhao et al. (2023), CLEVA. 公開説明例。 公開例 A2.SS1.SSS5.Px2 ／ 指示追従。</a:t>
+              <a:t>[1] Li et al. (2023). CLEVA. 公開説明例。</a:t>
             </a:r>
             <a:r>
               <a:rPr sz="810" b="0" lang="ja-JP" altLang="en-US">
@@ -26929,7 +25476,7 @@
                 <a:ea typeface="Noto Sans CJK JP"/>
                 <a:cs typeface="Noto Sans"/>
               </a:rPr>
-              <a:t>[1] Li, Zhao et al. (2023), CLEVA. 公開説明例。 公開例 A2.SS1.SSS3.Px2 ／ 帰納的推論。</a:t>
+              <a:t>[1] Li et al. (2023). CLEVA. 公開説明例。</a:t>
             </a:r>
             <a:r>
               <a:rPr sz="810" b="0" lang="ja-JP" altLang="en-US">
@@ -27101,7 +25648,7 @@
                 <a:ea typeface="Noto Sans CJK JP"/>
                 <a:cs typeface="Noto Sans"/>
               </a:rPr>
-              <a:t>課題、入力の整形、プロンプト、指標、モデルの呼出しをそろえて比較する。単一の正答率だけでモデルの性質を表さない。</a:t>
+              <a:t>課題、入力の整形、プロンプト、指標、モデルの呼び出しをそろえて比較する。正答率に加え、信頼性や生成文の性質も調べる。</a:t>
             </a:r>
           </a:p>
           <a:p>
@@ -27131,7 +25678,7 @@
                 <a:ea typeface="Noto Sans CJK JP"/>
                 <a:cs typeface="Noto Sans"/>
               </a:rPr>
-              <a:t>実務に近い11課題と、特定の能力を調べる20課題を含む。まず、公開されている三つの説明例を見る。</a:t>
+              <a:t>実務に近い11課題と、特定の能力を調べる20課題を含む。ここでは論文で公開された13の説明例に日本語訳を添え、入力と回答を紹介する。</a:t>
             </a:r>
           </a:p>
         </p:txBody>
@@ -27233,7 +25780,7 @@
                 <a:ea typeface="Noto Sans CJK JP"/>
                 <a:cs typeface="Noto Sans"/>
               </a:rPr>
-              <a:t>[1] Li, Zhao et al. (2023), CLEVA: Chinese Language Models EVAluation Platform. EMNLP System Demonstrations.</a:t>
+              <a:t>[1] Li et al. (2023). CLEVA. EMNLP System Demonstrations.</a:t>
             </a:r>
             <a:r>
               <a:rPr sz="810" b="0" lang="ja-JP" altLang="en-US">
@@ -27322,7 +25869,7 @@
                 <a:ea typeface="Noto Sans CJK JP"/>
                 <a:cs typeface="Noto Sans"/>
               </a:rPr>
-              <a:t>参照回答の単位と文脈を確かめる</a:t>
+              <a:t>知識の回答と、例から読み取る計算規則</a:t>
             </a:r>
           </a:p>
         </p:txBody>
@@ -27375,7 +25922,7 @@
                 <a:ea typeface="Noto Sans CJK JP"/>
                 <a:cs typeface="Noto Sans"/>
               </a:rPr>
-              <a:t>実例7では、数学の知識を、図形の名称という短い語で答える。参照ラベルは「四辺形」である。</a:t>
+              <a:t>実例7では、ブラーマグプタの公式について、対象となる図形の名称「四辺形」を答える。</a:t>
             </a:r>
           </a:p>
           <a:p>
@@ -27405,7 +25952,7 @@
                 <a:ea typeface="Noto Sans CJK JP"/>
                 <a:cs typeface="Noto Sans"/>
               </a:rPr>
-              <a:t>実例8は、2020年の第33回金鶏賞に関する主張。時点を外し、現在の受賞結果に関する質問として扱わない。</a:t>
+              <a:t>実例8は、2020年の第33回金鶏賞で、黄暁明と周冬雨が再び主演賞を受賞したという主張を判定する。</a:t>
             </a:r>
           </a:p>
           <a:p>
@@ -27435,7 +25982,7 @@
                 <a:ea typeface="Noto Sans CJK JP"/>
                 <a:cs typeface="Noto Sans"/>
               </a:rPr>
-              <a:t>実例13は、通常の和より1大きい値を返す規則を例から推定する。67＋987＝1054なので、提示された規則の参照値は1055。</a:t>
+              <a:t>実例13では、通常の和より1大きい値を返す規則を例から推定する。67＋987＝1054なので、同じ規則で得られる答えは1055となる。</a:t>
             </a:r>
           </a:p>
         </p:txBody>
@@ -27537,7 +26084,7 @@
                 <a:ea typeface="Noto Sans CJK JP"/>
                 <a:cs typeface="Noto Sans"/>
               </a:rPr>
-              <a:t>[1] Li, Zhao et al. (2023), CLEVA: Chinese Language Models EVAluation Platform. EMNLP System Demonstrations.</a:t>
+              <a:t>[1] Li et al. (2023). CLEVA. EMNLP System Demonstrations.</a:t>
             </a:r>
             <a:r>
               <a:rPr sz="810" b="0" lang="ja-JP" altLang="en-US">
@@ -27626,7 +26173,7 @@
                 <a:ea typeface="Noto Sans CJK JP"/>
                 <a:cs typeface="Noto Sans"/>
               </a:rPr>
-              <a:t>設定・統計・利用条件</a:t>
+              <a:t>課題の種類と評価の仕組み</a:t>
             </a:r>
           </a:p>
         </p:txBody>
@@ -27674,7 +26221,7 @@
                 <a:ea typeface="Noto Sans CJK JP"/>
                 <a:cs typeface="Noto Sans"/>
               </a:rPr>
-              <a:t>Appendix: 2. 設定・統計・利用条件</a:t>
+              <a:t>Appendix: 2. 課題の種類と評価の仕組み</a:t>
             </a:r>
           </a:p>
         </p:txBody>
@@ -27788,7 +26335,7 @@
                 <a:ea typeface="Noto Sans CJK JP"/>
                 <a:cs typeface="Noto Sans"/>
               </a:rPr>
-              <a:t>Appendix: 2. 設定・統計・利用条件</a:t>
+              <a:t>Appendix: 2. 課題の種類と評価の仕組み</a:t>
             </a:r>
           </a:p>
         </p:txBody>
@@ -28400,7 +26947,7 @@
                 <a:ea typeface="Noto Sans CJK JP"/>
                 <a:cs typeface="Noto Sans"/>
               </a:rPr>
-              <a:t>[1] Li, Zhao et al. (2023), CLEVA: Chinese Language Models EVAluation Platform. EMNLP System Demonstrations.</a:t>
+              <a:t>[1] Li et al. (2023). CLEVA. EMNLP System Demonstrations.</a:t>
             </a:r>
             <a:r>
               <a:rPr sz="810" b="0" lang="ja-JP" altLang="en-US">
@@ -28537,7 +27084,7 @@
                 <a:ea typeface="Noto Sans CJK JP"/>
                 <a:cs typeface="Noto Sans"/>
               </a:rPr>
-              <a:t>Appendix: 2. 設定・統計・利用条件</a:t>
+              <a:t>Appendix: 2. 課題の種類と評価の仕組み</a:t>
             </a:r>
           </a:p>
         </p:txBody>
@@ -29251,7 +27798,7 @@
                 <a:ea typeface="Noto Sans CJK JP"/>
                 <a:cs typeface="Noto Sans"/>
               </a:rPr>
-              <a:t>[1] Li, Zhao et al. (2023), CLEVA: Chinese Language Models EVAluation Platform. EMNLP System Demonstrations.</a:t>
+              <a:t>[1] Li et al. (2023). CLEVA. EMNLP System Demonstrations.</a:t>
             </a:r>
             <a:r>
               <a:rPr sz="810" b="0" lang="ja-JP" altLang="en-US">
@@ -29393,7 +27940,7 @@
                 <a:ea typeface="Noto Sans CJK JP"/>
                 <a:cs typeface="Noto Sans"/>
               </a:rPr>
-              <a:t>入力に何件の例を添えるかだけでなく、どの例をどの順に添えたかも回答に影響する。複数のテンプレートや乱数設定を使う評価では、集計する範囲をそろえる。</a:t>
+              <a:t>文脈内学習では、入力に正解付きの例を添えてモデルに解かせる。例の数に加え、どの例をどの順に示すかも回答に影響する。</a:t>
             </a:r>
           </a:p>
           <a:p>
@@ -29423,7 +27970,7 @@
                 <a:ea typeface="Noto Sans CJK JP"/>
                 <a:cs typeface="Noto Sans"/>
               </a:rPr>
-              <a:t>HELM実装は、ラベルの言い換え、項目の連結、選択肢の番号付けなどを行うConverterを持つ。元レコードのラベルと、モデルが実際に返す文字列を対応させる。</a:t>
+              <a:t>HELM実装のConverterは、ラベルの言い換え、項目の連結、選択肢の番号付けを行う。データ内のラベルを、プロンプトで指定した回答形式へ対応させる。</a:t>
             </a:r>
           </a:p>
         </p:txBody>
@@ -29471,7 +28018,7 @@
                 <a:ea typeface="Noto Sans CJK JP"/>
                 <a:cs typeface="Noto Sans"/>
               </a:rPr>
-              <a:t>Appendix: 2. 設定・統計・利用条件</a:t>
+              <a:t>Appendix: 2. 課題の種類と評価の仕組み</a:t>
             </a:r>
           </a:p>
         </p:txBody>
@@ -29525,22 +28072,19 @@
                 <a:ea typeface="Noto Sans CJK JP"/>
                 <a:cs typeface="Noto Sans"/>
               </a:rPr>
-              <a:t>[1] Stanford CRFM, HELM v0.4.0. CLEVA scenario / Converter.</a:t>
-            </a:r>
-          </a:p>
-          <a:p>
-            <a:pPr>
-              <a:lnSpc>
-                <a:spcPts val="940"/>
-              </a:lnSpc>
-              <a:buNone/>
-              <a:defRPr sz="810" b="0">
-                <a:solidFill>
-                  <a:srgbClr val="303437"/>
-                </a:solidFill>
-                <a:latin typeface="Noto Sans"/>
-              </a:defRPr>
-            </a:pPr>
+              <a:t>[1] Stanford CRFM (2023). HELM: CLEVA scenario.</a:t>
+            </a:r>
+            <a:r>
+              <a:rPr sz="810" b="0" lang="ja-JP" altLang="en-US">
+                <a:solidFill>
+                  <a:srgbClr val="626669"/>
+                </a:solidFill>
+                <a:latin typeface="Noto Sans"/>
+                <a:ea typeface="Noto Sans CJK JP"/>
+                <a:cs typeface="Noto Sans"/>
+              </a:rPr>
+              <a:t>  </a:t>
+            </a:r>
             <a:r>
               <a:rPr sz="810" b="0" lang="ja-JP" altLang="en-US">
                 <a:solidFill>
@@ -29730,7 +28274,7 @@
                 <a:ea typeface="Noto Sans CJK JP"/>
                 <a:cs typeface="Noto Sans"/>
               </a:rPr>
-              <a:t>2023年の評価ではAzureのPII検出サービスを使う。文字数に占める個人情報の割合ではなく、検出された事例の割合を測る。</a:t>
+              <a:t>2023年の評価ではAzureのPII検出サービスを使う。検出された事例の割合を測る。</a:t>
             </a:r>
           </a:p>
         </p:txBody>
@@ -29778,7 +28322,7 @@
                 <a:ea typeface="Noto Sans CJK JP"/>
                 <a:cs typeface="Noto Sans"/>
               </a:rPr>
-              <a:t>Appendix: 2. 設定・統計・利用条件</a:t>
+              <a:t>Appendix: 2. 課題の種類と評価の仕組み</a:t>
             </a:r>
           </a:p>
         </p:txBody>
@@ -29832,7 +28376,7 @@
                 <a:ea typeface="Noto Sans CJK JP"/>
                 <a:cs typeface="Noto Sans"/>
               </a:rPr>
-              <a:t>[1] Li, Zhao et al. (2023), CLEVA: Chinese Language Models EVAluation Platform. EMNLP System Demonstrations.</a:t>
+              <a:t>[1] Li et al. (2023). CLEVA. EMNLP System Demonstrations.</a:t>
             </a:r>
             <a:r>
               <a:rPr sz="810" b="0" lang="ja-JP" altLang="en-US">
@@ -29921,7 +28465,7 @@
                 <a:ea typeface="Noto Sans CJK JP"/>
                 <a:cs typeface="Noto Sans"/>
               </a:rPr>
-              <a:t>公開条件と、収録元の権利を確かめる</a:t>
+              <a:t>データの入手先で、利用条件を確認する</a:t>
             </a:r>
           </a:p>
         </p:txBody>
@@ -30007,36 +28551,6 @@
               <a:t>収録データの出所は一様ではない。元データの利用条件と、CLEVAが公開した加工済みデータの条件を、それぞれ確認する。</a:t>
             </a:r>
           </a:p>
-          <a:p>
-            <a:pPr marL="457200" indent="-355600">
-              <a:lnSpc>
-                <a:spcPts val="2618"/>
-              </a:lnSpc>
-              <a:spcAft>
-                <a:spcPts val="0"/>
-              </a:spcAft>
-              <a:buSzPct val="60455"/>
-              <a:buFont typeface="Noto Sans CJK JP"/>
-              <a:buChar char="●"/>
-              <a:defRPr sz="2200" b="0">
-                <a:solidFill>
-                  <a:srgbClr val="303437"/>
-                </a:solidFill>
-                <a:latin typeface="Noto Sans"/>
-              </a:defRPr>
-            </a:pPr>
-            <a:r>
-              <a:rPr sz="2200" b="0" lang="ja-JP" altLang="en-US">
-                <a:solidFill>
-                  <a:srgbClr val="303437"/>
-                </a:solidFill>
-                <a:latin typeface="Noto Sans"/>
-                <a:ea typeface="Noto Sans CJK JP"/>
-                <a:cs typeface="Noto Sans"/>
-              </a:rPr>
-              <a:t>この資料の日本語訳は、公開説明例を読むために添えたもの。CLEVAの公式訳や、公式評価ラベルではない。</a:t>
-            </a:r>
-          </a:p>
         </p:txBody>
       </p:sp>
       <p:sp>
@@ -30082,7 +28596,7 @@
                 <a:ea typeface="Noto Sans CJK JP"/>
                 <a:cs typeface="Noto Sans"/>
               </a:rPr>
-              <a:t>Appendix: 2. 設定・統計・利用条件</a:t>
+              <a:t>Appendix: 2. 課題の種類と評価の仕組み</a:t>
             </a:r>
           </a:p>
         </p:txBody>
@@ -30136,7 +28650,7 @@
                 <a:ea typeface="Noto Sans CJK JP"/>
                 <a:cs typeface="Noto Sans"/>
               </a:rPr>
-              <a:t>[1] LaVi Lab, CLEVA. 公式README・ローカル評価・参照結果・利用条件。</a:t>
+              <a:t>[1] LaVi Lab. CLEVA公式リポジトリ。</a:t>
             </a:r>
             <a:r>
               <a:rPr sz="810" b="0" lang="ja-JP" altLang="en-US">
@@ -30160,310 +28674,6 @@
                 <a:hlinkClick r:id="rId2"/>
               </a:rPr>
               <a:t>https://github.com/LaVi-Lab/CLEVA</a:t>
-            </a:r>
-          </a:p>
-        </p:txBody>
-      </p:sp>
-    </p:spTree>
-  </p:cSld>
-  <p:clrMapOvr>
-    <a:masterClrMapping/>
-  </p:clrMapOvr>
-</p:sld>
-</file>
-
-<file path=ppt/slides/slide57.xml><?xml version="1.0" encoding="utf-8"?>
-<p:sld xmlns:a="http://schemas.openxmlformats.org/drawingml/2006/main" xmlns:p="http://schemas.openxmlformats.org/presentationml/2006/main" xmlns:r="http://schemas.openxmlformats.org/officeDocument/2006/relationships">
-  <p:cSld>
-    <p:spTree>
-      <p:nvGrpSpPr>
-        <p:cNvPr id="1" name=""/>
-        <p:cNvGrpSpPr/>
-        <p:nvPr/>
-      </p:nvGrpSpPr>
-      <p:grpSpPr/>
-      <p:sp>
-        <p:nvSpPr>
-          <p:cNvPr id="2" name="Title 1"/>
-          <p:cNvSpPr>
-            <a:spLocks noGrp="1"/>
-          </p:cNvSpPr>
-          <p:nvPr>
-            <p:ph type="title"/>
-          </p:nvPr>
-        </p:nvSpPr>
-        <p:spPr>
-          <a:xfrm>
-            <a:off x="468172" y="650138"/>
-            <a:ext cx="8206740" cy="616305"/>
-          </a:xfrm>
-        </p:spPr>
-        <p:txBody>
-          <a:bodyPr wrap="square" lIns="0" rIns="0" tIns="0" bIns="0">
-            <a:noAutofit/>
-          </a:bodyPr>
-          <a:lstStyle/>
-          <a:p>
-            <a:pPr algn="l">
-              <a:lnSpc>
-                <a:spcPct val="110000"/>
-              </a:lnSpc>
-              <a:buNone/>
-              <a:defRPr sz="2800" b="0">
-                <a:solidFill>
-                  <a:srgbClr val="303437"/>
-                </a:solidFill>
-                <a:latin typeface="Noto Sans"/>
-              </a:defRPr>
-            </a:pPr>
-            <a:r>
-              <a:rPr sz="2800" b="1" lang="ja-JP" altLang="en-US">
-                <a:solidFill>
-                  <a:srgbClr val="303437"/>
-                </a:solidFill>
-                <a:latin typeface="Noto Sans"/>
-                <a:ea typeface="Noto Sans CJK JP"/>
-                <a:cs typeface="Noto Sans"/>
-              </a:rPr>
-              <a:t>後続のC²LEVAと、対象を分ける</a:t>
-            </a:r>
-          </a:p>
-        </p:txBody>
-      </p:sp>
-      <p:sp>
-        <p:nvSpPr>
-          <p:cNvPr id="3" name="Text Placeholder 2"/>
-          <p:cNvSpPr>
-            <a:spLocks noGrp="1"/>
-          </p:cNvSpPr>
-          <p:nvPr>
-            <p:ph type="body" idx="1"/>
-          </p:nvPr>
-        </p:nvSpPr>
-        <p:spPr>
-          <a:xfrm>
-            <a:off x="594360" y="1463040"/>
-            <a:ext cx="7955279" cy="3044952"/>
-          </a:xfrm>
-        </p:spPr>
-        <p:txBody>
-          <a:bodyPr wrap="square" tIns="91440" bIns="91440">
-            <a:noAutofit/>
-          </a:bodyPr>
-          <a:lstStyle/>
-          <a:p>
-            <a:pPr marL="457200" indent="-355600">
-              <a:lnSpc>
-                <a:spcPts val="2558"/>
-              </a:lnSpc>
-              <a:spcAft>
-                <a:spcPts val="700"/>
-              </a:spcAft>
-              <a:buSzPct val="61860"/>
-              <a:buFont typeface="Noto Sans CJK JP"/>
-              <a:buChar char="●"/>
-              <a:defRPr sz="2150" b="0">
-                <a:solidFill>
-                  <a:srgbClr val="303437"/>
-                </a:solidFill>
-                <a:latin typeface="Noto Sans"/>
-              </a:defRPr>
-            </a:pPr>
-            <a:r>
-              <a:rPr sz="2150" b="0" lang="ja-JP" altLang="en-US">
-                <a:solidFill>
-                  <a:srgbClr val="303437"/>
-                </a:solidFill>
-                <a:latin typeface="Noto Sans"/>
-                <a:ea typeface="Noto Sans CJK JP"/>
-                <a:cs typeface="Noto Sans"/>
-              </a:rPr>
-              <a:t>公式READMEは、後続のC²LEVAを2024年12月に案内し、2025年のFindings of ACLへの採択を報告している。</a:t>
-            </a:r>
-          </a:p>
-          <a:p>
-            <a:pPr marL="457200" indent="-355600">
-              <a:lnSpc>
-                <a:spcPts val="2558"/>
-              </a:lnSpc>
-              <a:spcAft>
-                <a:spcPts val="700"/>
-              </a:spcAft>
-              <a:buSzPct val="61860"/>
-              <a:buFont typeface="Noto Sans CJK JP"/>
-              <a:buChar char="●"/>
-              <a:defRPr sz="2150" b="0">
-                <a:solidFill>
-                  <a:srgbClr val="303437"/>
-                </a:solidFill>
-                <a:latin typeface="Noto Sans"/>
-              </a:defRPr>
-            </a:pPr>
-            <a:r>
-              <a:rPr sz="2150" b="0" lang="ja-JP" altLang="en-US">
-                <a:solidFill>
-                  <a:srgbClr val="303437"/>
-                </a:solidFill>
-                <a:latin typeface="Noto Sans"/>
-                <a:ea typeface="Noto Sans CJK JP"/>
-                <a:cs typeface="Noto Sans"/>
-              </a:rPr>
-              <a:t>C²LEVAは、英語と中国語を対象に、学習データへの混入を防ぐ仕組みを体系化する後続の評価。</a:t>
-            </a:r>
-          </a:p>
-          <a:p>
-            <a:pPr marL="457200" indent="-355600">
-              <a:lnSpc>
-                <a:spcPts val="2558"/>
-              </a:lnSpc>
-              <a:spcAft>
-                <a:spcPts val="0"/>
-              </a:spcAft>
-              <a:buSzPct val="61860"/>
-              <a:buFont typeface="Noto Sans CJK JP"/>
-              <a:buChar char="●"/>
-              <a:defRPr sz="2150" b="0">
-                <a:solidFill>
-                  <a:srgbClr val="303437"/>
-                </a:solidFill>
-                <a:latin typeface="Noto Sans"/>
-              </a:defRPr>
-            </a:pPr>
-            <a:r>
-              <a:rPr sz="2150" b="0" lang="ja-JP" altLang="en-US">
-                <a:solidFill>
-                  <a:srgbClr val="303437"/>
-                </a:solidFill>
-                <a:latin typeface="Noto Sans"/>
-                <a:ea typeface="Noto Sans CJK JP"/>
-                <a:cs typeface="Noto Sans"/>
-              </a:rPr>
-              <a:t>ここで扱う31課題・84データセット・約37万事例は、CLEVAの2023年の報告値。後続版の構成や結果へ、そのまま移さない。</a:t>
-            </a:r>
-          </a:p>
-        </p:txBody>
-      </p:sp>
-      <p:sp>
-        <p:nvSpPr>
-          <p:cNvPr id="4" name="Title 3"/>
-          <p:cNvSpPr>
-            <a:spLocks noGrp="1"/>
-          </p:cNvSpPr>
-          <p:nvPr>
-            <p:ph type="title" idx="2"/>
-          </p:nvPr>
-        </p:nvSpPr>
-        <p:spPr>
-          <a:xfrm>
-            <a:off x="75895" y="0"/>
-            <a:ext cx="8115300" cy="480060"/>
-          </a:xfrm>
-        </p:spPr>
-        <p:txBody>
-          <a:bodyPr wrap="square" lIns="0" rIns="0" tIns="0" bIns="0" anchor="ctr">
-            <a:noAutofit/>
-          </a:bodyPr>
-          <a:lstStyle/>
-          <a:p>
-            <a:pPr algn="l">
-              <a:lnSpc>
-                <a:spcPct val="110000"/>
-              </a:lnSpc>
-              <a:buNone/>
-              <a:defRPr sz="1400" b="0">
-                <a:solidFill>
-                  <a:srgbClr val="303437"/>
-                </a:solidFill>
-                <a:latin typeface="Noto Sans"/>
-              </a:defRPr>
-            </a:pPr>
-            <a:r>
-              <a:rPr sz="1400" b="1" lang="ja-JP" altLang="en-US">
-                <a:solidFill>
-                  <a:srgbClr val="FFFEF8"/>
-                </a:solidFill>
-                <a:latin typeface="Noto Sans"/>
-                <a:ea typeface="Noto Sans CJK JP"/>
-                <a:cs typeface="Noto Sans"/>
-              </a:rPr>
-              <a:t>Appendix: 2. 設定・統計・利用条件</a:t>
-            </a:r>
-          </a:p>
-        </p:txBody>
-      </p:sp>
-      <p:sp>
-        <p:nvSpPr>
-          <p:cNvPr id="5" name="sources"/>
-          <p:cNvSpPr txBox="1"/>
-          <p:nvPr/>
-        </p:nvSpPr>
-        <p:spPr>
-          <a:xfrm>
-            <a:off x="502920" y="4700016"/>
-            <a:ext cx="8183879" cy="530352"/>
-          </a:xfrm>
-          <a:prstGeom prst="rect">
-            <a:avLst/>
-          </a:prstGeom>
-          <a:noFill/>
-        </p:spPr>
-        <p:txBody>
-          <a:bodyPr wrap="square" lIns="0" rIns="0" tIns="0" bIns="0">
-            <a:noAutofit/>
-          </a:bodyPr>
-          <a:lstStyle/>
-          <a:p>
-            <a:pPr algn="l">
-              <a:lnSpc>
-                <a:spcPts val="940"/>
-              </a:lnSpc>
-              <a:spcBef>
-                <a:spcPts val="0"/>
-              </a:spcBef>
-              <a:spcAft>
-                <a:spcPts val="140"/>
-              </a:spcAft>
-              <a:buNone/>
-              <a:defRPr sz="810" b="0">
-                <a:solidFill>
-                  <a:srgbClr val="303437"/>
-                </a:solidFill>
-                <a:latin typeface="Noto Sans"/>
-              </a:defRPr>
-            </a:pPr>
-            <a:r>
-              <a:rPr sz="810" b="0" lang="ja-JP" altLang="en-US">
-                <a:solidFill>
-                  <a:srgbClr val="626669"/>
-                </a:solidFill>
-                <a:latin typeface="Noto Sans"/>
-                <a:ea typeface="Noto Sans CJK JP"/>
-                <a:cs typeface="Noto Sans"/>
-              </a:rPr>
-              <a:t>[1] Li et al., C²LEVA: Toward Comprehensive and Contamination-Free Language Model Evaluation. Findings of ACL 2025.</a:t>
-            </a:r>
-            <a:r>
-              <a:rPr sz="810" b="0" lang="ja-JP" altLang="en-US">
-                <a:solidFill>
-                  <a:srgbClr val="626669"/>
-                </a:solidFill>
-                <a:latin typeface="Noto Sans"/>
-                <a:ea typeface="Noto Sans CJK JP"/>
-                <a:cs typeface="Noto Sans"/>
-              </a:rPr>
-              <a:t>  </a:t>
-            </a:r>
-            <a:r>
-              <a:rPr sz="810" b="0" lang="ja-JP" altLang="en-US">
-                <a:solidFill>
-                  <a:srgbClr val="626669"/>
-                </a:solidFill>
-                <a:latin typeface="Noto Sans"/>
-                <a:ea typeface="Noto Sans CJK JP"/>
-                <a:cs typeface="Noto Sans"/>
-                <a:hlinkClick r:id="rId2"/>
-              </a:rPr>
-              <a:t>https://arxiv.org/abs/2412.04947</a:t>
             </a:r>
           </a:p>
         </p:txBody>
@@ -30696,7 +28906,7 @@
                 <a:ea typeface="Noto Sans CJK JP"/>
                 <a:cs typeface="Noto Sans"/>
               </a:rPr>
-              <a:t>Yanyang LiとJianqiao Zhaoが共同第一著者、Liwei Wangが責任著者。香港中文大学と上海AI実験室の研究者が参加した。</a:t>
+              <a:t>共同第一著者はYanyang LiとJianqiao Zhao、責任著者はLiwei Wang。香港中文大学と上海AI実験室が、2023年のEMNLPで発表した。</a:t>
             </a:r>
           </a:p>
           <a:p>
@@ -30726,37 +28936,7 @@
                 <a:ea typeface="Noto Sans CJK JP"/>
                 <a:cs typeface="Noto Sans"/>
               </a:rPr>
-              <a:t>2023年のEMNLP System Demonstrationsで、ベンチマーク、評価手順、オンラインの利用例とモデル比較を報告している。</a:t>
-            </a:r>
-          </a:p>
-          <a:p>
-            <a:pPr marL="457200" indent="-355600">
-              <a:lnSpc>
-                <a:spcPts val="2618"/>
-              </a:lnSpc>
-              <a:spcAft>
-                <a:spcPts val="0"/>
-              </a:spcAft>
-              <a:buSzPct val="60455"/>
-              <a:buFont typeface="Noto Sans CJK JP"/>
-              <a:buChar char="●"/>
-              <a:defRPr sz="2200" b="0">
-                <a:solidFill>
-                  <a:srgbClr val="303437"/>
-                </a:solidFill>
-                <a:latin typeface="Noto Sans"/>
-              </a:defRPr>
-            </a:pPr>
-            <a:r>
-              <a:rPr sz="2200" b="0" lang="ja-JP" altLang="en-US">
-                <a:solidFill>
-                  <a:srgbClr val="303437"/>
-                </a:solidFill>
-                <a:latin typeface="Noto Sans"/>
-                <a:ea typeface="Noto Sans CJK JP"/>
-                <a:cs typeface="Noto Sans"/>
-              </a:rPr>
-              <a:t>公開リポジトリにはHELM統合の手順が追加され、オンライン評価とローカル評価の二つの入口が示されている。</a:t>
+              <a:t>後続のC²LEVAは英語と中国語を扱い、学習データへの混入を防ぐ仕組みを体系化する。2025年のFindings of ACLに発表された。</a:t>
             </a:r>
           </a:p>
         </p:txBody>
@@ -30858,7 +29038,7 @@
                 <a:ea typeface="Noto Sans CJK JP"/>
                 <a:cs typeface="Noto Sans"/>
               </a:rPr>
-              <a:t>[1] Li, Zhao et al. (2023), CLEVA: Chinese Language Models EVAluation Platform. EMNLP System Demonstrations.</a:t>
+              <a:t>[1] Li et al. (2023). CLEVA. EMNLP System Demonstrations.</a:t>
             </a:r>
             <a:r>
               <a:rPr sz="810" b="0" lang="ja-JP" altLang="en-US">
@@ -30884,264 +29064,11 @@
               <a:t>https://aclanthology.org/2023.emnlp-demo.17/</a:t>
             </a:r>
           </a:p>
-        </p:txBody>
-      </p:sp>
-    </p:spTree>
-  </p:cSld>
-  <p:clrMapOvr>
-    <a:masterClrMapping/>
-  </p:clrMapOvr>
-</p:sld>
-</file>
-
-<file path=ppt/slides/slide6.xml><?xml version="1.0" encoding="utf-8"?>
-<p:sld xmlns:a="http://schemas.openxmlformats.org/drawingml/2006/main" xmlns:p="http://schemas.openxmlformats.org/presentationml/2006/main" xmlns:r="http://schemas.openxmlformats.org/officeDocument/2006/relationships">
-  <p:cSld>
-    <p:spTree>
-      <p:nvGrpSpPr>
-        <p:cNvPr id="1" name=""/>
-        <p:cNvGrpSpPr/>
-        <p:nvPr/>
-      </p:nvGrpSpPr>
-      <p:grpSpPr/>
-      <p:sp>
-        <p:nvSpPr>
-          <p:cNvPr id="2" name="Title 1"/>
-          <p:cNvSpPr>
-            <a:spLocks noGrp="1"/>
-          </p:cNvSpPr>
-          <p:nvPr>
-            <p:ph type="title"/>
-          </p:nvPr>
-        </p:nvSpPr>
-        <p:spPr>
-          <a:xfrm>
-            <a:off x="468172" y="650138"/>
-            <a:ext cx="8206740" cy="616305"/>
-          </a:xfrm>
-        </p:spPr>
-        <p:txBody>
-          <a:bodyPr wrap="square" lIns="0" rIns="0" tIns="0" bIns="0">
-            <a:noAutofit/>
-          </a:bodyPr>
-          <a:lstStyle/>
-          <a:p>
-            <a:pPr algn="l">
-              <a:lnSpc>
-                <a:spcPct val="110000"/>
-              </a:lnSpc>
-              <a:buNone/>
-              <a:defRPr sz="2800" b="0">
-                <a:solidFill>
-                  <a:srgbClr val="303437"/>
-                </a:solidFill>
-                <a:latin typeface="Noto Sans"/>
-              </a:defRPr>
-            </a:pPr>
-            <a:r>
-              <a:rPr sz="2800" b="1" lang="ja-JP" altLang="en-US">
-                <a:solidFill>
-                  <a:srgbClr val="303437"/>
-                </a:solidFill>
-                <a:latin typeface="Noto Sans"/>
-                <a:ea typeface="Noto Sans CJK JP"/>
-                <a:cs typeface="Noto Sans"/>
-              </a:rPr>
-              <a:t>公開例と、評価集合を区別する</a:t>
-            </a:r>
-          </a:p>
-        </p:txBody>
-      </p:sp>
-      <p:sp>
-        <p:nvSpPr>
-          <p:cNvPr id="3" name="Text Placeholder 2"/>
-          <p:cNvSpPr>
-            <a:spLocks noGrp="1"/>
-          </p:cNvSpPr>
-          <p:nvPr>
-            <p:ph type="body" idx="1"/>
-          </p:nvPr>
-        </p:nvSpPr>
-        <p:spPr>
-          <a:xfrm>
-            <a:off x="594360" y="1463040"/>
-            <a:ext cx="7955279" cy="3044952"/>
-          </a:xfrm>
-        </p:spPr>
-        <p:txBody>
-          <a:bodyPr wrap="square" tIns="91440" bIns="91440">
-            <a:noAutofit/>
-          </a:bodyPr>
-          <a:lstStyle/>
-          <a:p>
-            <a:pPr marL="457200" indent="-355600">
-              <a:lnSpc>
-                <a:spcPts val="2439"/>
-              </a:lnSpc>
-              <a:spcAft>
-                <a:spcPts val="700"/>
-              </a:spcAft>
-              <a:buSzPct val="64878"/>
-              <a:buFont typeface="Noto Sans CJK JP"/>
-              <a:buChar char="●"/>
-              <a:defRPr sz="2050" b="0">
-                <a:solidFill>
-                  <a:srgbClr val="303437"/>
-                </a:solidFill>
-                <a:latin typeface="Noto Sans"/>
-              </a:defRPr>
-            </a:pPr>
-            <a:r>
-              <a:rPr sz="2050" b="0" lang="ja-JP" altLang="en-US">
-                <a:solidFill>
-                  <a:srgbClr val="303437"/>
-                </a:solidFill>
-                <a:latin typeface="Noto Sans"/>
-                <a:ea typeface="Noto Sans CJK JP"/>
-                <a:cs typeface="Noto Sans"/>
-              </a:rPr>
-              <a:t>本編3件と追加10件は、CLEVA論文で公開された課題の説明例。印刷された入力・選択肢・回答を対応させ、日本語訳を添えた。</a:t>
-            </a:r>
-          </a:p>
-          <a:p>
-            <a:pPr marL="457200" indent="-355600">
-              <a:lnSpc>
-                <a:spcPts val="2439"/>
-              </a:lnSpc>
-              <a:spcAft>
-                <a:spcPts val="700"/>
-              </a:spcAft>
-              <a:buSzPct val="64878"/>
-              <a:buFont typeface="Noto Sans CJK JP"/>
-              <a:buChar char="●"/>
-              <a:defRPr sz="2050" b="0">
-                <a:solidFill>
-                  <a:srgbClr val="303437"/>
-                </a:solidFill>
-                <a:latin typeface="Noto Sans"/>
-              </a:defRPr>
-            </a:pPr>
-            <a:r>
-              <a:rPr sz="2050" b="0" lang="ja-JP" altLang="en-US">
-                <a:solidFill>
-                  <a:srgbClr val="303437"/>
-                </a:solidFill>
-                <a:latin typeface="Noto Sans"/>
-                <a:ea typeface="Noto Sans CJK JP"/>
-                <a:cs typeface="Noto Sans"/>
-              </a:rPr>
-              <a:t>元データの評価IDや、実行時の全テンプレートを復元したものではない。課題によっては、説明例の中に省略記号もある。</a:t>
-            </a:r>
-          </a:p>
-          <a:p>
-            <a:pPr marL="457200" indent="-355600">
-              <a:lnSpc>
-                <a:spcPts val="2439"/>
-              </a:lnSpc>
-              <a:spcAft>
-                <a:spcPts val="0"/>
-              </a:spcAft>
-              <a:buSzPct val="64878"/>
-              <a:buFont typeface="Noto Sans CJK JP"/>
-              <a:buChar char="●"/>
-              <a:defRPr sz="2050" b="0">
-                <a:solidFill>
-                  <a:srgbClr val="303437"/>
-                </a:solidFill>
-                <a:latin typeface="Noto Sans"/>
-              </a:defRPr>
-            </a:pPr>
-            <a:r>
-              <a:rPr sz="2050" b="0" lang="ja-JP" altLang="en-US">
-                <a:solidFill>
-                  <a:srgbClr val="303437"/>
-                </a:solidFill>
-                <a:latin typeface="Noto Sans"/>
-                <a:ea typeface="Noto Sans CJK JP"/>
-                <a:cs typeface="Noto Sans"/>
-              </a:rPr>
-              <a:t>個別データセットの収集方法や評価は、それぞれの資料で扱う。ここでは、CLEVAの評価手順と結果の読み方を説明する。</a:t>
-            </a:r>
-          </a:p>
-        </p:txBody>
-      </p:sp>
-      <p:sp>
-        <p:nvSpPr>
-          <p:cNvPr id="4" name="Title 3"/>
-          <p:cNvSpPr>
-            <a:spLocks noGrp="1"/>
-          </p:cNvSpPr>
-          <p:nvPr>
-            <p:ph type="title" idx="2"/>
-          </p:nvPr>
-        </p:nvSpPr>
-        <p:spPr>
-          <a:xfrm>
-            <a:off x="75895" y="0"/>
-            <a:ext cx="8115300" cy="480060"/>
-          </a:xfrm>
-        </p:spPr>
-        <p:txBody>
-          <a:bodyPr wrap="square" lIns="0" rIns="0" tIns="0" bIns="0" anchor="ctr">
-            <a:noAutofit/>
-          </a:bodyPr>
-          <a:lstStyle/>
-          <a:p>
-            <a:pPr algn="l">
-              <a:lnSpc>
-                <a:spcPct val="110000"/>
-              </a:lnSpc>
-              <a:buNone/>
-              <a:defRPr sz="1400" b="0">
-                <a:solidFill>
-                  <a:srgbClr val="303437"/>
-                </a:solidFill>
-                <a:latin typeface="Noto Sans"/>
-              </a:defRPr>
-            </a:pPr>
-            <a:r>
-              <a:rPr sz="1400" b="1" lang="ja-JP" altLang="en-US">
-                <a:solidFill>
-                  <a:srgbClr val="FFFEF8"/>
-                </a:solidFill>
-                <a:latin typeface="Noto Sans"/>
-                <a:ea typeface="Noto Sans CJK JP"/>
-                <a:cs typeface="Noto Sans"/>
-              </a:rPr>
-              <a:t>1. 公開例から見る中国語評価</a:t>
-            </a:r>
-          </a:p>
-        </p:txBody>
-      </p:sp>
-      <p:sp>
-        <p:nvSpPr>
-          <p:cNvPr id="5" name="sources"/>
-          <p:cNvSpPr txBox="1"/>
-          <p:nvPr/>
-        </p:nvSpPr>
-        <p:spPr>
-          <a:xfrm>
-            <a:off x="502920" y="4700016"/>
-            <a:ext cx="8183879" cy="530352"/>
-          </a:xfrm>
-          <a:prstGeom prst="rect">
-            <a:avLst/>
-          </a:prstGeom>
-          <a:noFill/>
-        </p:spPr>
-        <p:txBody>
-          <a:bodyPr wrap="square" lIns="0" rIns="0" tIns="0" bIns="0">
-            <a:noAutofit/>
-          </a:bodyPr>
-          <a:lstStyle/>
-          <a:p>
-            <a:pPr algn="l">
+          <a:p>
+            <a:pPr>
               <a:lnSpc>
                 <a:spcPts val="940"/>
               </a:lnSpc>
-              <a:spcBef>
-                <a:spcPts val="0"/>
-              </a:spcBef>
               <a:spcAft>
                 <a:spcPts val="140"/>
               </a:spcAft>
@@ -31162,7 +29089,7 @@
                 <a:ea typeface="Noto Sans CJK JP"/>
                 <a:cs typeface="Noto Sans"/>
               </a:rPr>
-              <a:t>[1] Li, Zhao et al. (2023), CLEVA: Chinese Language Models EVAluation Platform. EMNLP System Demonstrations.</a:t>
+              <a:t>[2] Li et al. (2025). C²LEVA. Findings of ACL.</a:t>
             </a:r>
             <a:r>
               <a:rPr sz="810" b="0" lang="ja-JP" altLang="en-US">
@@ -31183,9 +29110,9 @@
                 <a:latin typeface="Noto Sans"/>
                 <a:ea typeface="Noto Sans CJK JP"/>
                 <a:cs typeface="Noto Sans"/>
-                <a:hlinkClick r:id="rId2"/>
-              </a:rPr>
-              <a:t>https://aclanthology.org/2023.emnlp-demo.17/</a:t>
+                <a:hlinkClick r:id="rId3"/>
+              </a:rPr>
+              <a:t>https://arxiv.org/abs/2412.04947</a:t>
             </a:r>
           </a:p>
         </p:txBody>
@@ -31532,7 +29459,7 @@
                 <a:ea typeface="Noto Sans CJK JP"/>
                 <a:cs typeface="Noto Sans"/>
               </a:rPr>
-              <a:t>LaVi Lab · 公式リポジトリ</a:t>
+              <a:t>LaVi Lab (n.d.). 公式リポジトリ。参照2026-10-19。</a:t>
             </a:r>
           </a:p>
           <a:p>
@@ -32268,6 +30195,154 @@
                 <a:hlinkClick r:id="rId2"/>
               </a:rPr>
               <a:t>https://github.com/stanford-crfm/helm/blob/v0.4.0/src/helm/benchmark/scenarios/cleva_scenario.py</a:t>
+            </a:r>
+          </a:p>
+        </p:txBody>
+      </p:sp>
+      <p:sp>
+        <p:nvSpPr>
+          <p:cNvPr id="5" name="文献 2: CC BY-NC-ND 4.0"/>
+          <p:cNvSpPr txBox="1"/>
+          <p:nvPr/>
+        </p:nvSpPr>
+        <p:spPr>
+          <a:xfrm>
+            <a:off x="548640" y="3108960"/>
+            <a:ext cx="8046720" cy="1645920"/>
+          </a:xfrm>
+          <a:prstGeom prst="rect">
+            <a:avLst/>
+          </a:prstGeom>
+          <a:noFill/>
+        </p:spPr>
+        <p:txBody>
+          <a:bodyPr wrap="square" lIns="0" rIns="0" tIns="0" bIns="0">
+            <a:noAutofit/>
+          </a:bodyPr>
+          <a:lstStyle/>
+          <a:p>
+            <a:pPr algn="l">
+              <a:lnSpc>
+                <a:spcPct val="114000"/>
+              </a:lnSpc>
+              <a:spcBef>
+                <a:spcPts val="0"/>
+              </a:spcBef>
+              <a:spcAft>
+                <a:spcPts val="400"/>
+              </a:spcAft>
+              <a:buNone/>
+              <a:defRPr sz="1600" b="0">
+                <a:solidFill>
+                  <a:srgbClr val="303437"/>
+                </a:solidFill>
+                <a:latin typeface="Noto Sans"/>
+              </a:defRPr>
+            </a:pPr>
+            <a:r>
+              <a:rPr sz="1700" b="1" lang="ja-JP" altLang="en-US">
+                <a:solidFill>
+                  <a:srgbClr val="303437"/>
+                </a:solidFill>
+                <a:latin typeface="Noto Sans"/>
+                <a:ea typeface="Noto Sans CJK JP"/>
+                <a:cs typeface="Noto Sans"/>
+              </a:rPr>
+              <a:t>Attribution-NonCommercial-NoDerivatives 4.0 International</a:t>
+            </a:r>
+          </a:p>
+          <a:p>
+            <a:pPr algn="l">
+              <a:lnSpc>
+                <a:spcPct val="114000"/>
+              </a:lnSpc>
+              <a:spcBef>
+                <a:spcPts val="0"/>
+              </a:spcBef>
+              <a:spcAft>
+                <a:spcPts val="400"/>
+              </a:spcAft>
+              <a:buNone/>
+              <a:defRPr sz="1600" b="0">
+                <a:solidFill>
+                  <a:srgbClr val="303437"/>
+                </a:solidFill>
+                <a:latin typeface="Noto Sans"/>
+              </a:defRPr>
+            </a:pPr>
+            <a:r>
+              <a:rPr sz="1200" b="0" lang="ja-JP" altLang="en-US">
+                <a:solidFill>
+                  <a:srgbClr val="626669"/>
+                </a:solidFill>
+                <a:latin typeface="Noto Sans"/>
+                <a:ea typeface="Noto Sans CJK JP"/>
+                <a:cs typeface="Noto Sans"/>
+              </a:rPr>
+              <a:t>Creative Commons (n.d.). CC BY-NC-ND 4.0。参照2026-10-19。</a:t>
+            </a:r>
+          </a:p>
+          <a:p>
+            <a:pPr algn="l">
+              <a:lnSpc>
+                <a:spcPct val="114000"/>
+              </a:lnSpc>
+              <a:spcBef>
+                <a:spcPts val="0"/>
+              </a:spcBef>
+              <a:spcAft>
+                <a:spcPts val="400"/>
+              </a:spcAft>
+              <a:buNone/>
+              <a:defRPr sz="1600" b="0">
+                <a:solidFill>
+                  <a:srgbClr val="303437"/>
+                </a:solidFill>
+                <a:latin typeface="Noto Sans"/>
+              </a:defRPr>
+            </a:pPr>
+            <a:r>
+              <a:rPr sz="1600" b="0" lang="ja-JP" altLang="en-US">
+                <a:solidFill>
+                  <a:srgbClr val="303437"/>
+                </a:solidFill>
+                <a:latin typeface="Noto Sans"/>
+                <a:ea typeface="Noto Sans CJK JP"/>
+                <a:cs typeface="Noto Sans"/>
+              </a:rPr>
+              <a:t>公式リポジトリのライセンス。非商用・帰属表示・改変物の共有に関する条件を定める。</a:t>
+            </a:r>
+          </a:p>
+          <a:p>
+            <a:pPr algn="l">
+              <a:lnSpc>
+                <a:spcPct val="114000"/>
+              </a:lnSpc>
+              <a:spcBef>
+                <a:spcPts val="0"/>
+              </a:spcBef>
+              <a:spcAft>
+                <a:spcPts val="400"/>
+              </a:spcAft>
+              <a:buNone/>
+              <a:defRPr sz="1600" b="0">
+                <a:solidFill>
+                  <a:srgbClr val="303437"/>
+                </a:solidFill>
+                <a:latin typeface="Noto Sans"/>
+              </a:defRPr>
+            </a:pPr>
+            <a:r>
+              <a:rPr sz="1150" b="0" lang="ja-JP" altLang="en-US">
+                <a:solidFill>
+                  <a:srgbClr val="626669"/>
+                </a:solidFill>
+                <a:latin typeface="Noto Sans"/>
+                <a:ea typeface="Noto Sans CJK JP"/>
+                <a:cs typeface="Noto Sans"/>
+                <a:hlinkClick r:id="rId3"/>
+              </a:rPr>
+              <a:t>https://creativecommons.org/licenses/by-nc-nd/4.0/</a:t>
             </a:r>
           </a:p>
         </p:txBody>
@@ -32668,7 +30743,7 @@
                 <a:ea typeface="Noto Sans CJK JP"/>
                 <a:cs typeface="Noto Sans"/>
               </a:rPr>
-              <a:t>蒋盈波が以前所属していた研究室の准教授が、学術行事に参加するためドイツへ行った。そこで中国系ドイツ人の同業者と知り合い、その同業者は彼を自宅に一度招いた。話すうちに、二人とも、偶然が重なるものだ、世界は狭いものだと感じた。</a:t>
+              <a:t>蒋盈波が以前所属していた教育・研究部門の准教授が、学術行事に参加するためドイツへ行った。そこで中国系ドイツ人の同業者と知り合い、その同業者は彼を自宅に一度招いた。話すうちに、二人とも、偶然が重なるものだ、世界は狭いものだと感じた。</a:t>
             </a:r>
           </a:p>
           <a:p>
@@ -32861,7 +30936,7 @@
                 <a:ea typeface="Noto Sans CJK JP"/>
                 <a:cs typeface="Noto Sans"/>
               </a:rPr>
-              <a:t>[1] Li, Zhao et al. (2023), CLEVA. 公開説明例。 公開例 A2.SS1.SSS1.Px2 ／ 共参照解決。</a:t>
+              <a:t>[1] Li et al. (2023). CLEVA. 公開説明例。</a:t>
             </a:r>
             <a:r>
               <a:rPr sz="810" b="0" lang="ja-JP" altLang="en-US">
@@ -32950,7 +31025,7 @@
                 <a:ea typeface="Noto Sans CJK JP"/>
                 <a:cs typeface="Noto Sans"/>
               </a:rPr>
-              <a:t>指示対象を、文脈から区別する</a:t>
+              <a:t>文脈から、代名詞が指す人を選ぶ</a:t>
             </a:r>
           </a:p>
         </p:txBody>
@@ -33003,7 +31078,7 @@
                 <a:ea typeface="Noto Sans CJK JP"/>
                 <a:cs typeface="Noto Sans"/>
               </a:rPr>
-              <a:t>実例1では、自宅に招かれた人が、准教授と同業者のどちらなのかを区別する。参照回答は「同業者ではない」。</a:t>
+              <a:t>実例1では、自宅に招かれた人が、准教授と同業者のどちらなのかを問う。招かれたのは准教授なので、参照回答は「同業者ではない」。</a:t>
             </a:r>
           </a:p>
           <a:p>
@@ -33033,7 +31108,7 @@
                 <a:ea typeface="Noto Sans CJK JP"/>
                 <a:cs typeface="Noto Sans"/>
               </a:rPr>
-              <a:t>CLEVAはCLUEWSCからこの課題を採り、代名詞と候補の人物を示す二択の質問へ整形している。出力の解釈には、質問の形と回答ラベルの対応が必要になる。</a:t>
+              <a:t>CLEVAはCLUEWSCを用い、代名詞と候補の人物を示す二択の質問へ整形している。元の判定を、中国語の「是／否」で答えられる形にした。</a:t>
             </a:r>
           </a:p>
         </p:txBody>
@@ -33135,7 +31210,7 @@
                 <a:ea typeface="Noto Sans CJK JP"/>
                 <a:cs typeface="Noto Sans"/>
               </a:rPr>
-              <a:t>[1] Li, Zhao et al. (2023), CLEVA: Chinese Language Models EVAluation Platform. EMNLP System Demonstrations.</a:t>
+              <a:t>[1] Li et al. (2023). CLEVA. EMNLP System Demonstrations.</a:t>
             </a:r>
             <a:r>
               <a:rPr sz="810" b="0" lang="ja-JP" altLang="en-US">
@@ -33791,7 +31866,7 @@
                 <a:ea typeface="Noto Sans CJK JP"/>
                 <a:cs typeface="Noto Sans"/>
               </a:rPr>
-              <a:t>[1] Li, Zhao et al. (2023), CLEVA. 公開説明例。 公開例 A2.SS2.SSS0.Px1 ／ C3。</a:t>
+              <a:t>[1] Li et al. (2023). CLEVA. 公開説明例。</a:t>
             </a:r>
             <a:r>
               <a:rPr sz="810" b="0" lang="ja-JP" altLang="en-US">

</xml_diff>